<commit_message>
Update Smart Opinion Survey Platform.pptx
</commit_message>
<xml_diff>
--- a/Smart Opinion Survey Platform.pptx
+++ b/Smart Opinion Survey Platform.pptx
@@ -11,6 +11,10 @@
     <p:sldId id="259" r:id="rId5"/>
     <p:sldId id="260" r:id="rId6"/>
     <p:sldId id="261" r:id="rId7"/>
+    <p:sldId id="263" r:id="rId8"/>
+    <p:sldId id="264" r:id="rId9"/>
+    <p:sldId id="262" r:id="rId10"/>
+    <p:sldId id="265" r:id="rId11"/>
   </p:sldIdLst>
   <p:sldSz cx="12192000" cy="6858000"/>
   <p:notesSz cx="6858000" cy="9144000"/>
@@ -264,7 +268,7 @@
           <a:p>
             <a:fld id="{096A8431-2457-4B17-8EAD-CB7DD7790385}" type="datetimeFigureOut">
               <a:rPr lang="ar-SA" smtClean="0"/>
-              <a:t>18/09/47</a:t>
+              <a:t>19/09/47</a:t>
             </a:fld>
             <a:endParaRPr lang="ar-SA"/>
           </a:p>
@@ -462,7 +466,7 @@
           <a:p>
             <a:fld id="{096A8431-2457-4B17-8EAD-CB7DD7790385}" type="datetimeFigureOut">
               <a:rPr lang="ar-SA" smtClean="0"/>
-              <a:t>18/09/47</a:t>
+              <a:t>19/09/47</a:t>
             </a:fld>
             <a:endParaRPr lang="ar-SA"/>
           </a:p>
@@ -670,7 +674,7 @@
           <a:p>
             <a:fld id="{096A8431-2457-4B17-8EAD-CB7DD7790385}" type="datetimeFigureOut">
               <a:rPr lang="ar-SA" smtClean="0"/>
-              <a:t>18/09/47</a:t>
+              <a:t>19/09/47</a:t>
             </a:fld>
             <a:endParaRPr lang="ar-SA"/>
           </a:p>
@@ -868,7 +872,7 @@
           <a:p>
             <a:fld id="{096A8431-2457-4B17-8EAD-CB7DD7790385}" type="datetimeFigureOut">
               <a:rPr lang="ar-SA" smtClean="0"/>
-              <a:t>18/09/47</a:t>
+              <a:t>19/09/47</a:t>
             </a:fld>
             <a:endParaRPr lang="ar-SA"/>
           </a:p>
@@ -1143,7 +1147,7 @@
           <a:p>
             <a:fld id="{096A8431-2457-4B17-8EAD-CB7DD7790385}" type="datetimeFigureOut">
               <a:rPr lang="ar-SA" smtClean="0"/>
-              <a:t>18/09/47</a:t>
+              <a:t>19/09/47</a:t>
             </a:fld>
             <a:endParaRPr lang="ar-SA"/>
           </a:p>
@@ -1408,7 +1412,7 @@
           <a:p>
             <a:fld id="{096A8431-2457-4B17-8EAD-CB7DD7790385}" type="datetimeFigureOut">
               <a:rPr lang="ar-SA" smtClean="0"/>
-              <a:t>18/09/47</a:t>
+              <a:t>19/09/47</a:t>
             </a:fld>
             <a:endParaRPr lang="ar-SA"/>
           </a:p>
@@ -1820,7 +1824,7 @@
           <a:p>
             <a:fld id="{096A8431-2457-4B17-8EAD-CB7DD7790385}" type="datetimeFigureOut">
               <a:rPr lang="ar-SA" smtClean="0"/>
-              <a:t>18/09/47</a:t>
+              <a:t>19/09/47</a:t>
             </a:fld>
             <a:endParaRPr lang="ar-SA"/>
           </a:p>
@@ -1961,7 +1965,7 @@
           <a:p>
             <a:fld id="{096A8431-2457-4B17-8EAD-CB7DD7790385}" type="datetimeFigureOut">
               <a:rPr lang="ar-SA" smtClean="0"/>
-              <a:t>18/09/47</a:t>
+              <a:t>19/09/47</a:t>
             </a:fld>
             <a:endParaRPr lang="ar-SA"/>
           </a:p>
@@ -2074,7 +2078,7 @@
           <a:p>
             <a:fld id="{096A8431-2457-4B17-8EAD-CB7DD7790385}" type="datetimeFigureOut">
               <a:rPr lang="ar-SA" smtClean="0"/>
-              <a:t>18/09/47</a:t>
+              <a:t>19/09/47</a:t>
             </a:fld>
             <a:endParaRPr lang="ar-SA"/>
           </a:p>
@@ -2385,7 +2389,7 @@
           <a:p>
             <a:fld id="{096A8431-2457-4B17-8EAD-CB7DD7790385}" type="datetimeFigureOut">
               <a:rPr lang="ar-SA" smtClean="0"/>
-              <a:t>18/09/47</a:t>
+              <a:t>19/09/47</a:t>
             </a:fld>
             <a:endParaRPr lang="ar-SA"/>
           </a:p>
@@ -2673,7 +2677,7 @@
           <a:p>
             <a:fld id="{096A8431-2457-4B17-8EAD-CB7DD7790385}" type="datetimeFigureOut">
               <a:rPr lang="ar-SA" smtClean="0"/>
-              <a:t>18/09/47</a:t>
+              <a:t>19/09/47</a:t>
             </a:fld>
             <a:endParaRPr lang="ar-SA"/>
           </a:p>
@@ -2914,7 +2918,7 @@
           <a:p>
             <a:fld id="{096A8431-2457-4B17-8EAD-CB7DD7790385}" type="datetimeFigureOut">
               <a:rPr lang="ar-SA" smtClean="0"/>
-              <a:t>18/09/47</a:t>
+              <a:t>19/09/47</a:t>
             </a:fld>
             <a:endParaRPr lang="ar-SA"/>
           </a:p>
@@ -3685,6 +3689,83 @@
 </p:sld>
 </file>
 
+<file path=ppt/slides/slide10.xml><?xml version="1.0" encoding="utf-8"?>
+<p:sld xmlns:a="http://schemas.openxmlformats.org/drawingml/2006/main" xmlns:r="http://schemas.openxmlformats.org/officeDocument/2006/relationships" xmlns:p="http://schemas.openxmlformats.org/presentationml/2006/main">
+  <p:cSld>
+    <p:spTree>
+      <p:nvGrpSpPr>
+        <p:cNvPr id="1" name=""/>
+        <p:cNvGrpSpPr/>
+        <p:nvPr/>
+      </p:nvGrpSpPr>
+      <p:grpSpPr>
+        <a:xfrm>
+          <a:off x="0" y="0"/>
+          <a:ext cx="0" cy="0"/>
+          <a:chOff x="0" y="0"/>
+          <a:chExt cx="0" cy="0"/>
+        </a:xfrm>
+      </p:grpSpPr>
+      <p:pic>
+        <p:nvPicPr>
+          <p:cNvPr id="3074" name="Picture 2">
+            <a:extLst>
+              <a:ext uri="{FF2B5EF4-FFF2-40B4-BE49-F238E27FC236}">
+                <a16:creationId xmlns:a16="http://schemas.microsoft.com/office/drawing/2014/main" id="{8DD57BF0-A466-1E14-8F00-579B0A9C3D84}"/>
+              </a:ext>
+            </a:extLst>
+          </p:cNvPr>
+          <p:cNvPicPr>
+            <a:picLocks noChangeAspect="1" noChangeArrowheads="1"/>
+          </p:cNvPicPr>
+          <p:nvPr/>
+        </p:nvPicPr>
+        <p:blipFill>
+          <a:blip r:embed="rId2">
+            <a:extLst>
+              <a:ext uri="{28A0092B-C50C-407E-A947-70E740481C1C}">
+                <a14:useLocalDpi xmlns:a14="http://schemas.microsoft.com/office/drawing/2010/main" val="0"/>
+              </a:ext>
+            </a:extLst>
+          </a:blip>
+          <a:srcRect/>
+          <a:stretch>
+            <a:fillRect/>
+          </a:stretch>
+        </p:blipFill>
+        <p:spPr bwMode="auto">
+          <a:xfrm>
+            <a:off x="1390261" y="0"/>
+            <a:ext cx="10245011" cy="6858000"/>
+          </a:xfrm>
+          <a:prstGeom prst="rect">
+            <a:avLst/>
+          </a:prstGeom>
+          <a:noFill/>
+          <a:extLst>
+            <a:ext uri="{909E8E84-426E-40DD-AFC4-6F175D3DCCD1}">
+              <a14:hiddenFill xmlns:a14="http://schemas.microsoft.com/office/drawing/2010/main">
+                <a:solidFill>
+                  <a:srgbClr val="FFFFFF"/>
+                </a:solidFill>
+              </a14:hiddenFill>
+            </a:ext>
+          </a:extLst>
+        </p:spPr>
+      </p:pic>
+    </p:spTree>
+    <p:extLst>
+      <p:ext uri="{BB962C8B-B14F-4D97-AF65-F5344CB8AC3E}">
+        <p14:creationId xmlns:p14="http://schemas.microsoft.com/office/powerpoint/2010/main" val="1238364110"/>
+      </p:ext>
+    </p:extLst>
+  </p:cSld>
+  <p:clrMapOvr>
+    <a:masterClrMapping/>
+  </p:clrMapOvr>
+</p:sld>
+</file>
+
 <file path=ppt/slides/slide2.xml><?xml version="1.0" encoding="utf-8"?>
 <p:sld xmlns:a="http://schemas.openxmlformats.org/drawingml/2006/main" xmlns:r="http://schemas.openxmlformats.org/officeDocument/2006/relationships" xmlns:p="http://schemas.openxmlformats.org/presentationml/2006/main">
   <p:cSld>
@@ -3717,7 +3798,7 @@
         <p:spPr>
           <a:xfrm>
             <a:off x="746448" y="74645"/>
-            <a:ext cx="10314991" cy="2817438"/>
+            <a:ext cx="10314991" cy="2850589"/>
           </a:xfrm>
           <a:prstGeom prst="rect">
             <a:avLst/>
@@ -3742,7 +3823,7 @@
               </a:spcAft>
             </a:pPr>
             <a:r>
-              <a:rPr lang="ar-SA" b="1" dirty="0">
+              <a:rPr lang="ar-SA" sz="2000" b="1" dirty="0">
                 <a:solidFill>
                   <a:srgbClr val="2F5496"/>
                 </a:solidFill>
@@ -3752,7 +3833,7 @@
               </a:rPr>
               <a:t>مقدمة عن المشروع</a:t>
             </a:r>
-            <a:endParaRPr lang="en-US" b="1" dirty="0">
+            <a:endParaRPr lang="en-US" sz="2000" b="1" dirty="0">
               <a:solidFill>
                 <a:srgbClr val="2F5496"/>
               </a:solidFill>
@@ -3863,7 +3944,7 @@
         <p:spPr>
           <a:xfrm>
             <a:off x="1562877" y="2792739"/>
-            <a:ext cx="9498562" cy="1749197"/>
+            <a:ext cx="9498562" cy="1795363"/>
           </a:xfrm>
           <a:prstGeom prst="rect">
             <a:avLst/>
@@ -4308,7 +4389,7 @@
             </a:r>
             <a:r>
               <a:rPr lang="ar-SA" dirty="0"/>
-              <a:t> بناء النظام كـ "تطبيق ويب" (</a:t>
+              <a:t> بناء النظام كـ "تطبيق ويب"</a:t>
             </a:r>
             <a:r>
               <a:rPr lang="en-US" dirty="0"/>
@@ -4316,7 +4397,7 @@
             </a:r>
             <a:r>
               <a:rPr lang="ar-SA" dirty="0"/>
-              <a:t>متجاوب، والاعتماد على نماذج ذكاء اصطناعي مدربة مسبقاً (</a:t>
+              <a:t>) متجاوب، والاعتماد على نماذج ذكاء اصطناعي مدربة مسبقاً</a:t>
             </a:r>
             <a:r>
               <a:rPr lang="en-US" dirty="0"/>
@@ -4324,7 +4405,7 @@
             </a:r>
             <a:r>
               <a:rPr lang="ar-SA" dirty="0"/>
-              <a:t>لتحليل النصوص.</a:t>
+              <a:t>) لتحليل النصوص.</a:t>
             </a:r>
           </a:p>
           <a:p>
@@ -4345,7 +4426,7 @@
             </a:r>
             <a:r>
               <a:rPr lang="en-US" dirty="0"/>
-              <a:t>Mobile App)، </a:t>
+              <a:t>(Mobile App، </a:t>
             </a:r>
             <a:r>
               <a:rPr lang="ar-SA" dirty="0"/>
@@ -4525,12 +4606,450 @@
           </a:p>
         </p:txBody>
       </p:sp>
+      <p:sp>
+        <p:nvSpPr>
+          <p:cNvPr id="6" name="مربع نص 5">
+            <a:extLst>
+              <a:ext uri="{FF2B5EF4-FFF2-40B4-BE49-F238E27FC236}">
+                <a16:creationId xmlns:a16="http://schemas.microsoft.com/office/drawing/2014/main" id="{4FBF6A0A-C59A-595C-077B-309D8FBEDF45}"/>
+              </a:ext>
+            </a:extLst>
+          </p:cNvPr>
+          <p:cNvSpPr txBox="1"/>
+          <p:nvPr/>
+        </p:nvSpPr>
+        <p:spPr>
+          <a:xfrm>
+            <a:off x="0" y="3004540"/>
+            <a:ext cx="11532636" cy="3826689"/>
+          </a:xfrm>
+          <a:prstGeom prst="rect">
+            <a:avLst/>
+          </a:prstGeom>
+          <a:noFill/>
+        </p:spPr>
+        <p:txBody>
+          <a:bodyPr wrap="square">
+            <a:spAutoFit/>
+          </a:bodyPr>
+          <a:lstStyle/>
+          <a:p>
+            <a:pPr>
+              <a:lnSpc>
+                <a:spcPct val="150000"/>
+              </a:lnSpc>
+            </a:pPr>
+            <a:r>
+              <a:rPr lang="ar-SA" sz="2000" b="1" dirty="0">
+                <a:solidFill>
+                  <a:schemeClr val="accent1"/>
+                </a:solidFill>
+              </a:rPr>
+              <a:t>الدراسة المرجعية </a:t>
+            </a:r>
+            <a:endParaRPr lang="en-US" sz="2000" dirty="0">
+              <a:solidFill>
+                <a:schemeClr val="accent1"/>
+              </a:solidFill>
+            </a:endParaRPr>
+          </a:p>
+          <a:p>
+            <a:pPr>
+              <a:lnSpc>
+                <a:spcPct val="150000"/>
+              </a:lnSpc>
+              <a:buFont typeface="Arial" panose="020B0604020202020204" pitchFamily="34" charset="0"/>
+              <a:buChar char="•"/>
+            </a:pPr>
+            <a:r>
+              <a:rPr lang="ar-SA" b="1" dirty="0"/>
+              <a:t>النهج التقليدي في الأبحاث السابقة:</a:t>
+            </a:r>
+            <a:r>
+              <a:rPr lang="ar-SA" dirty="0"/>
+              <a:t> ركزت معظم الدراسات السابقة على بناء استبيانات إلكترونية تقليدية تعتمد على النشر العشوائي للروابط، مما أدى إلى نتائج تعاني من "تحيز العينة" (</a:t>
+            </a:r>
+            <a:r>
+              <a:rPr lang="en-US" dirty="0"/>
+              <a:t>.(Sample Bias</a:t>
+            </a:r>
+          </a:p>
+          <a:p>
+            <a:pPr>
+              <a:lnSpc>
+                <a:spcPct val="150000"/>
+              </a:lnSpc>
+              <a:buFont typeface="Arial" panose="020B0604020202020204" pitchFamily="34" charset="0"/>
+              <a:buChar char="•"/>
+            </a:pPr>
+            <a:r>
+              <a:rPr lang="ar-SA" b="1" dirty="0"/>
+              <a:t>الدراسات المعتمدة على الذكاء الاصطناعي:</a:t>
+            </a:r>
+            <a:r>
+              <a:rPr lang="ar-SA" dirty="0"/>
+              <a:t> الأبحاث الحديثة التي استخدمت معالجة اللغات الطبيعية (</a:t>
+            </a:r>
+            <a:r>
+              <a:rPr lang="en-US" dirty="0"/>
+              <a:t>(NLP</a:t>
+            </a:r>
+            <a:r>
+              <a:rPr lang="ar-SA" dirty="0"/>
+              <a:t> لتحليل الاستبيانات، غالباً ما كانت تطبق التحليل كـ "مرحلة منفصلة" (</a:t>
+            </a:r>
+            <a:r>
+              <a:rPr lang="en-US" dirty="0"/>
+              <a:t>Post-processing </a:t>
+            </a:r>
+            <a:r>
+              <a:rPr lang="ar-SA" dirty="0"/>
+              <a:t>) بعد جمع البيانات، وليست مدمجة في صلب المنصة.</a:t>
+            </a:r>
+          </a:p>
+          <a:p>
+            <a:pPr>
+              <a:lnSpc>
+                <a:spcPct val="150000"/>
+              </a:lnSpc>
+              <a:buFont typeface="Arial" panose="020B0604020202020204" pitchFamily="34" charset="0"/>
+              <a:buChar char="•"/>
+            </a:pPr>
+            <a:r>
+              <a:rPr lang="ar-SA" b="1" dirty="0"/>
+              <a:t>الفجوة البحثية (</a:t>
+            </a:r>
+            <a:r>
+              <a:rPr lang="en-US" b="1" dirty="0"/>
+              <a:t> (Research Gap</a:t>
+            </a:r>
+            <a:r>
+              <a:rPr lang="ar-SA" dirty="0"/>
+              <a:t>تفتقر الدراسات والأنظمة الحالية إلى وجود </a:t>
+            </a:r>
+            <a:r>
+              <a:rPr lang="ar-SA" b="1" dirty="0"/>
+              <a:t>"بيئة ثنائية الأطراف متكاملة"</a:t>
+            </a:r>
+            <a:r>
+              <a:rPr lang="ar-SA" dirty="0"/>
+              <a:t> تجمع بين:</a:t>
+            </a:r>
+          </a:p>
+          <a:p>
+            <a:pPr marL="742950" lvl="1" indent="-285750">
+              <a:lnSpc>
+                <a:spcPct val="150000"/>
+              </a:lnSpc>
+              <a:buFont typeface="Arial" panose="020B0604020202020204" pitchFamily="34" charset="0"/>
+              <a:buChar char="•"/>
+            </a:pPr>
+            <a:r>
+              <a:rPr lang="ar-SA" dirty="0"/>
+              <a:t>الاستهداف الآلي والمسبق للمجيبين (لضمان دقة العينة).</a:t>
+            </a:r>
+          </a:p>
+          <a:p>
+            <a:pPr marL="742950" lvl="1" indent="-285750">
+              <a:lnSpc>
+                <a:spcPct val="150000"/>
+              </a:lnSpc>
+              <a:buFont typeface="Arial" panose="020B0604020202020204" pitchFamily="34" charset="0"/>
+              <a:buChar char="•"/>
+            </a:pPr>
+            <a:r>
+              <a:rPr lang="ar-SA" dirty="0"/>
+              <a:t>التحليل الآلي والفوري للمشاعر (</a:t>
+            </a:r>
+            <a:r>
+              <a:rPr lang="en-US" dirty="0"/>
+              <a:t>NLP </a:t>
+            </a:r>
+            <a:r>
+              <a:rPr lang="ar-SA" dirty="0"/>
+              <a:t>) داخل نفس النظام.</a:t>
+            </a:r>
+          </a:p>
+          <a:p>
+            <a:pPr>
+              <a:lnSpc>
+                <a:spcPct val="150000"/>
+              </a:lnSpc>
+              <a:buFont typeface="Arial" panose="020B0604020202020204" pitchFamily="34" charset="0"/>
+              <a:buChar char="•"/>
+            </a:pPr>
+            <a:r>
+              <a:rPr lang="ar-SA" b="1" dirty="0"/>
+              <a:t>مساهمة مشروعنا:</a:t>
+            </a:r>
+            <a:r>
+              <a:rPr lang="ar-SA" dirty="0"/>
+              <a:t> تقديم حل هندسي يدمج محرك الاستهداف الذكي مع نماذج الذكاء الاصطناعي في منصة واحدة متكاملة.</a:t>
+            </a:r>
+          </a:p>
+        </p:txBody>
+      </p:sp>
+    </p:spTree>
+    <p:extLst>
+      <p:ext uri="{BB962C8B-B14F-4D97-AF65-F5344CB8AC3E}">
+        <p14:creationId xmlns:p14="http://schemas.microsoft.com/office/powerpoint/2010/main" val="2218134423"/>
+      </p:ext>
+    </p:extLst>
+  </p:cSld>
+  <p:clrMapOvr>
+    <a:masterClrMapping/>
+  </p:clrMapOvr>
+</p:sld>
+</file>
+
+<file path=ppt/slides/slide5.xml><?xml version="1.0" encoding="utf-8"?>
+<p:sld xmlns:a="http://schemas.openxmlformats.org/drawingml/2006/main" xmlns:r="http://schemas.openxmlformats.org/officeDocument/2006/relationships" xmlns:p="http://schemas.openxmlformats.org/presentationml/2006/main">
+  <p:cSld>
+    <p:spTree>
+      <p:nvGrpSpPr>
+        <p:cNvPr id="1" name=""/>
+        <p:cNvGrpSpPr/>
+        <p:nvPr/>
+      </p:nvGrpSpPr>
+      <p:grpSpPr>
+        <a:xfrm>
+          <a:off x="0" y="0"/>
+          <a:ext cx="0" cy="0"/>
+          <a:chOff x="0" y="0"/>
+          <a:chExt cx="0" cy="0"/>
+        </a:xfrm>
+      </p:grpSpPr>
+      <p:sp>
+        <p:nvSpPr>
+          <p:cNvPr id="3" name="مربع نص 2">
+            <a:extLst>
+              <a:ext uri="{FF2B5EF4-FFF2-40B4-BE49-F238E27FC236}">
+                <a16:creationId xmlns:a16="http://schemas.microsoft.com/office/drawing/2014/main" id="{590F3AF2-F4E8-4B17-0D30-4D06D9D13AB2}"/>
+              </a:ext>
+            </a:extLst>
+          </p:cNvPr>
+          <p:cNvSpPr txBox="1"/>
+          <p:nvPr/>
+        </p:nvSpPr>
+        <p:spPr>
+          <a:xfrm>
+            <a:off x="130629" y="3862308"/>
+            <a:ext cx="10991634" cy="2995692"/>
+          </a:xfrm>
+          <a:prstGeom prst="rect">
+            <a:avLst/>
+          </a:prstGeom>
+          <a:noFill/>
+        </p:spPr>
+        <p:txBody>
+          <a:bodyPr wrap="square">
+            <a:spAutoFit/>
+          </a:bodyPr>
+          <a:lstStyle/>
+          <a:p>
+            <a:pPr>
+              <a:lnSpc>
+                <a:spcPct val="150000"/>
+              </a:lnSpc>
+            </a:pPr>
+            <a:r>
+              <a:rPr lang="ar-SA" sz="2000" b="1" dirty="0">
+                <a:solidFill>
+                  <a:schemeClr val="accent1"/>
+                </a:solidFill>
+              </a:rPr>
+              <a:t>الأدوات والتقنيات المستخدمة </a:t>
+            </a:r>
+          </a:p>
+          <a:p>
+            <a:pPr>
+              <a:lnSpc>
+                <a:spcPct val="150000"/>
+              </a:lnSpc>
+            </a:pPr>
+            <a:r>
+              <a:rPr lang="ar-SA" b="1" dirty="0"/>
+              <a:t>الواجهة الخلفية (</a:t>
+            </a:r>
+            <a:r>
+              <a:rPr lang="en-US" b="1" dirty="0"/>
+              <a:t> :(Backend</a:t>
+            </a:r>
+            <a:r>
+              <a:rPr lang="ar-SA" dirty="0"/>
+              <a:t>لغة البرمجة </a:t>
+            </a:r>
+            <a:r>
+              <a:rPr lang="en-US" b="1" dirty="0"/>
+              <a:t>Python</a:t>
+            </a:r>
+            <a:r>
+              <a:rPr lang="en-US" dirty="0"/>
+              <a:t> </a:t>
+            </a:r>
+            <a:r>
+              <a:rPr lang="ar-SA" dirty="0"/>
+              <a:t> بالاعتماد على إطار العمل </a:t>
+            </a:r>
+            <a:r>
+              <a:rPr lang="en-US" dirty="0"/>
+              <a:t> (</a:t>
+            </a:r>
+            <a:r>
+              <a:rPr lang="en-US" b="1" dirty="0"/>
+              <a:t>Django)</a:t>
+            </a:r>
+            <a:r>
+              <a:rPr lang="ar-SA" dirty="0"/>
+              <a:t>لبناء بنية تحتية قوية، آمنة، وقابلة للتوسع.</a:t>
+            </a:r>
+          </a:p>
+          <a:p>
+            <a:pPr>
+              <a:lnSpc>
+                <a:spcPct val="150000"/>
+              </a:lnSpc>
+            </a:pPr>
+            <a:r>
+              <a:rPr lang="ar-SA" b="1" dirty="0"/>
+              <a:t> قواعد البيانات </a:t>
+            </a:r>
+            <a:r>
+              <a:rPr lang="en-US" b="1" dirty="0"/>
+              <a:t> :(Database)</a:t>
+            </a:r>
+            <a:r>
+              <a:rPr lang="ar-SA" dirty="0"/>
+              <a:t>قواعد بيانات علائقية</a:t>
+            </a:r>
+            <a:r>
+              <a:rPr lang="en-US" dirty="0"/>
+              <a:t> (</a:t>
+            </a:r>
+            <a:r>
+              <a:rPr lang="en-US" b="1" dirty="0"/>
+              <a:t>SQL) </a:t>
+            </a:r>
+            <a:r>
+              <a:rPr lang="ar-SA" dirty="0"/>
+              <a:t>لإدارة الملفات الشخصية، شروط الاستهداف، والردود بدقة وموثوقية.</a:t>
+            </a:r>
+          </a:p>
+          <a:p>
+            <a:pPr>
+              <a:lnSpc>
+                <a:spcPct val="150000"/>
+              </a:lnSpc>
+            </a:pPr>
+            <a:r>
+              <a:rPr lang="ar-SA" b="1" dirty="0"/>
+              <a:t> الواجهة الأمامية (</a:t>
+            </a:r>
+            <a:r>
+              <a:rPr lang="en-US" b="1" dirty="0"/>
+              <a:t>Frontend</a:t>
+            </a:r>
+            <a:r>
+              <a:rPr lang="ar-SA" b="1" dirty="0"/>
+              <a:t>): </a:t>
+            </a:r>
+            <a:r>
+              <a:rPr lang="ar-SA" dirty="0"/>
+              <a:t>تقنيات الويب القياسية </a:t>
+            </a:r>
+            <a:r>
+              <a:rPr lang="en-US" dirty="0"/>
+              <a:t> (HTML, CSS, JavaScript) </a:t>
+            </a:r>
+            <a:r>
+              <a:rPr lang="ar-SA" dirty="0"/>
+              <a:t>لتصميم واجهات مستخدم (</a:t>
+            </a:r>
+            <a:r>
+              <a:rPr lang="en-US" dirty="0"/>
+              <a:t>UI</a:t>
+            </a:r>
+            <a:r>
+              <a:rPr lang="ar-SA" dirty="0"/>
+              <a:t>) متجاوبة وسهلة الاستخدام.</a:t>
+            </a:r>
+          </a:p>
+          <a:p>
+            <a:pPr>
+              <a:lnSpc>
+                <a:spcPct val="150000"/>
+              </a:lnSpc>
+            </a:pPr>
+            <a:r>
+              <a:rPr lang="ar-SA" b="1" dirty="0"/>
+              <a:t> الذكاء الاصطناعي (</a:t>
+            </a:r>
+            <a:r>
+              <a:rPr lang="en-US" b="1" dirty="0"/>
+              <a:t> :(AI &amp; NLP</a:t>
+            </a:r>
+            <a:r>
+              <a:rPr lang="ar-SA" dirty="0"/>
+              <a:t>استغلال بيئة </a:t>
+            </a:r>
+            <a:r>
+              <a:rPr lang="en-US" dirty="0"/>
+              <a:t> Python </a:t>
+            </a:r>
+            <a:r>
+              <a:rPr lang="ar-SA" dirty="0"/>
+              <a:t>لدمج مكتبات ونماذج معالجة اللغات الطبيعية (لتحليل المشاعر واستخراج التوجهات).</a:t>
+            </a:r>
+          </a:p>
+          <a:p>
+            <a:pPr>
+              <a:lnSpc>
+                <a:spcPct val="150000"/>
+              </a:lnSpc>
+            </a:pPr>
+            <a:r>
+              <a:rPr lang="ar-SA" b="1" dirty="0"/>
+              <a:t>بيئة العمل الجماعي (</a:t>
+            </a:r>
+            <a:r>
+              <a:rPr lang="en-US" b="1" dirty="0"/>
+              <a:t>Version Control</a:t>
+            </a:r>
+            <a:r>
+              <a:rPr lang="ar-SA" b="1" dirty="0"/>
+              <a:t>): </a:t>
+            </a:r>
+            <a:r>
+              <a:rPr lang="ar-SA" dirty="0"/>
+              <a:t>استخدام </a:t>
+            </a:r>
+            <a:r>
+              <a:rPr lang="en-US" b="1" dirty="0"/>
+              <a:t>GitHub</a:t>
+            </a:r>
+            <a:r>
+              <a:rPr lang="ar-SA" dirty="0"/>
+              <a:t> لإدارة الأكواد وتنظيم العمل المشترك بين أعضاء الفريق.</a:t>
+            </a:r>
+          </a:p>
+          <a:p>
+            <a:pPr>
+              <a:lnSpc>
+                <a:spcPct val="150000"/>
+              </a:lnSpc>
+              <a:buFont typeface="Arial" panose="020B0604020202020204" pitchFamily="34" charset="0"/>
+              <a:buChar char="•"/>
+            </a:pPr>
+            <a:endParaRPr lang="ar-SA" dirty="0"/>
+          </a:p>
+        </p:txBody>
+      </p:sp>
       <p:graphicFrame>
         <p:nvGraphicFramePr>
           <p:cNvPr id="2" name="جدول 1">
             <a:extLst>
               <a:ext uri="{FF2B5EF4-FFF2-40B4-BE49-F238E27FC236}">
-                <a16:creationId xmlns:a16="http://schemas.microsoft.com/office/drawing/2014/main" id="{17853753-72BB-5FEF-D502-D72BF06791E2}"/>
+                <a16:creationId xmlns:a16="http://schemas.microsoft.com/office/drawing/2014/main" id="{5BD70ED0-19DD-4D96-8DEF-CDAFF24FDAEF}"/>
               </a:ext>
             </a:extLst>
           </p:cNvPr>
@@ -4540,14 +5059,14 @@
           <p:nvPr>
             <p:extLst>
               <p:ext uri="{D42A27DB-BD31-4B8C-83A1-F6EECF244321}">
-                <p14:modId xmlns:p14="http://schemas.microsoft.com/office/powerpoint/2010/main" val="1030643634"/>
+                <p14:modId xmlns:p14="http://schemas.microsoft.com/office/powerpoint/2010/main" val="2752978139"/>
               </p:ext>
             </p:extLst>
           </p:nvPr>
         </p:nvGraphicFramePr>
         <p:xfrm>
-          <a:off x="1488828" y="3310467"/>
-          <a:ext cx="8785473" cy="3029517"/>
+          <a:off x="1847461" y="93306"/>
+          <a:ext cx="9079983" cy="3278981"/>
         </p:xfrm>
         <a:graphic>
           <a:graphicData uri="http://schemas.openxmlformats.org/drawingml/2006/table">
@@ -4556,28 +5075,28 @@
                 <a:tableStyleId>{5C22544A-7EE6-4342-B048-85BDC9FD1C3A}</a:tableStyleId>
               </a:tblPr>
               <a:tblGrid>
-                <a:gridCol w="1841054">
+                <a:gridCol w="1902771">
                   <a:extLst>
                     <a:ext uri="{9D8B030D-6E8A-4147-A177-3AD203B41FA5}">
                       <a16:colId xmlns:a16="http://schemas.microsoft.com/office/drawing/2014/main" val="1950653663"/>
                     </a:ext>
                   </a:extLst>
                 </a:gridCol>
-                <a:gridCol w="1827679">
+                <a:gridCol w="1888948">
                   <a:extLst>
                     <a:ext uri="{9D8B030D-6E8A-4147-A177-3AD203B41FA5}">
                       <a16:colId xmlns:a16="http://schemas.microsoft.com/office/drawing/2014/main" val="3310257874"/>
                     </a:ext>
                   </a:extLst>
                 </a:gridCol>
-                <a:gridCol w="2058968">
+                <a:gridCol w="2127989">
                   <a:extLst>
                     <a:ext uri="{9D8B030D-6E8A-4147-A177-3AD203B41FA5}">
                       <a16:colId xmlns:a16="http://schemas.microsoft.com/office/drawing/2014/main" val="1449973089"/>
                     </a:ext>
                   </a:extLst>
                 </a:gridCol>
-                <a:gridCol w="3057772">
+                <a:gridCol w="3160275">
                   <a:extLst>
                     <a:ext uri="{9D8B030D-6E8A-4147-A177-3AD203B41FA5}">
                       <a16:colId xmlns:a16="http://schemas.microsoft.com/office/drawing/2014/main" val="3274840695"/>
@@ -4585,7 +5104,7 @@
                   </a:extLst>
                 </a:gridCol>
               </a:tblGrid>
-              <a:tr h="489207">
+              <a:tr h="529490">
                 <a:tc>
                   <a:txBody>
                     <a:bodyPr/>
@@ -4717,12 +5236,12 @@
                         </a:spcAft>
                       </a:pPr>
                       <a:r>
-                        <a:rPr lang="ar-SA" sz="1400" kern="100">
+                        <a:rPr lang="ar-SA" sz="1400" kern="100" dirty="0">
                           <a:effectLst/>
                         </a:rPr>
-                        <a:t>المنصة المقترحة (مشروعك)</a:t>
+                        <a:t>المنصة المقترحة (منصة استبيانات الآراء الذكية)</a:t>
                       </a:r>
-                      <a:endParaRPr lang="en-US" sz="1100" kern="100">
+                      <a:endParaRPr lang="en-US" sz="1100" kern="100" dirty="0">
                         <a:effectLst/>
                         <a:latin typeface="Calibri" panose="020F0502020204030204" pitchFamily="34" charset="0"/>
                         <a:ea typeface="Times New Roman" panose="02020603050405020304" pitchFamily="18" charset="0"/>
@@ -4738,7 +5257,7 @@
                   </a:ext>
                 </a:extLst>
               </a:tr>
-              <a:tr h="501196">
+              <a:tr h="542467">
                 <a:tc>
                   <a:txBody>
                     <a:bodyPr/>
@@ -4861,7 +5380,7 @@
                   </a:ext>
                 </a:extLst>
               </a:tr>
-              <a:tr h="540110">
+              <a:tr h="584585">
                 <a:tc>
                   <a:txBody>
                     <a:bodyPr/>
@@ -4990,7 +5509,7 @@
                   </a:ext>
                 </a:extLst>
               </a:tr>
-              <a:tr h="499668">
+              <a:tr h="540813">
                 <a:tc>
                   <a:txBody>
                     <a:bodyPr/>
@@ -5113,7 +5632,7 @@
                   </a:ext>
                 </a:extLst>
               </a:tr>
-              <a:tr h="499668">
+              <a:tr h="540813">
                 <a:tc>
                   <a:txBody>
                     <a:bodyPr/>
@@ -5236,7 +5755,7 @@
                   </a:ext>
                 </a:extLst>
               </a:tr>
-              <a:tr h="499668">
+              <a:tr h="540813">
                 <a:tc>
                   <a:txBody>
                     <a:bodyPr/>
@@ -5371,10 +5890,10 @@
       </p:graphicFrame>
       <p:sp>
         <p:nvSpPr>
-          <p:cNvPr id="3" name="Rectangle 1">
-            <a:extLst>
-              <a:ext uri="{FF2B5EF4-FFF2-40B4-BE49-F238E27FC236}">
-                <a16:creationId xmlns:a16="http://schemas.microsoft.com/office/drawing/2014/main" id="{AB6EE6E6-A843-67E4-5B43-A9EC121EE565}"/>
+          <p:cNvPr id="4" name="Rectangle 1">
+            <a:extLst>
+              <a:ext uri="{FF2B5EF4-FFF2-40B4-BE49-F238E27FC236}">
+                <a16:creationId xmlns:a16="http://schemas.microsoft.com/office/drawing/2014/main" id="{5C8CD114-3F11-4178-619F-7DA26E5A59B6}"/>
               </a:ext>
             </a:extLst>
           </p:cNvPr>
@@ -5385,7 +5904,7 @@
         </p:nvSpPr>
         <p:spPr bwMode="auto">
           <a:xfrm>
-            <a:off x="4288366" y="6339983"/>
+            <a:off x="4288366" y="3372288"/>
             <a:ext cx="3615267" cy="369283"/>
           </a:xfrm>
           <a:prstGeom prst="rect">
@@ -5610,226 +6129,6 @@
     </p:spTree>
     <p:extLst>
       <p:ext uri="{BB962C8B-B14F-4D97-AF65-F5344CB8AC3E}">
-        <p14:creationId xmlns:p14="http://schemas.microsoft.com/office/powerpoint/2010/main" val="2218134423"/>
-      </p:ext>
-    </p:extLst>
-  </p:cSld>
-  <p:clrMapOvr>
-    <a:masterClrMapping/>
-  </p:clrMapOvr>
-</p:sld>
-</file>
-
-<file path=ppt/slides/slide5.xml><?xml version="1.0" encoding="utf-8"?>
-<p:sld xmlns:a="http://schemas.openxmlformats.org/drawingml/2006/main" xmlns:r="http://schemas.openxmlformats.org/officeDocument/2006/relationships" xmlns:p="http://schemas.openxmlformats.org/presentationml/2006/main">
-  <p:cSld>
-    <p:spTree>
-      <p:nvGrpSpPr>
-        <p:cNvPr id="1" name=""/>
-        <p:cNvGrpSpPr/>
-        <p:nvPr/>
-      </p:nvGrpSpPr>
-      <p:grpSpPr>
-        <a:xfrm>
-          <a:off x="0" y="0"/>
-          <a:ext cx="0" cy="0"/>
-          <a:chOff x="0" y="0"/>
-          <a:chExt cx="0" cy="0"/>
-        </a:xfrm>
-      </p:grpSpPr>
-      <p:sp>
-        <p:nvSpPr>
-          <p:cNvPr id="3" name="مربع نص 2">
-            <a:extLst>
-              <a:ext uri="{FF2B5EF4-FFF2-40B4-BE49-F238E27FC236}">
-                <a16:creationId xmlns:a16="http://schemas.microsoft.com/office/drawing/2014/main" id="{590F3AF2-F4E8-4B17-0D30-4D06D9D13AB2}"/>
-              </a:ext>
-            </a:extLst>
-          </p:cNvPr>
-          <p:cNvSpPr txBox="1"/>
-          <p:nvPr/>
-        </p:nvSpPr>
-        <p:spPr>
-          <a:xfrm>
-            <a:off x="1024468" y="256739"/>
-            <a:ext cx="10312398" cy="2995692"/>
-          </a:xfrm>
-          <a:prstGeom prst="rect">
-            <a:avLst/>
-          </a:prstGeom>
-          <a:noFill/>
-        </p:spPr>
-        <p:txBody>
-          <a:bodyPr wrap="square">
-            <a:spAutoFit/>
-          </a:bodyPr>
-          <a:lstStyle/>
-          <a:p>
-            <a:pPr>
-              <a:lnSpc>
-                <a:spcPct val="150000"/>
-              </a:lnSpc>
-            </a:pPr>
-            <a:r>
-              <a:rPr lang="ar-SA" sz="2000" b="1" dirty="0">
-                <a:solidFill>
-                  <a:schemeClr val="accent1"/>
-                </a:solidFill>
-              </a:rPr>
-              <a:t>بيئة العمل والتقنيات </a:t>
-            </a:r>
-          </a:p>
-          <a:p>
-            <a:pPr>
-              <a:lnSpc>
-                <a:spcPct val="150000"/>
-              </a:lnSpc>
-            </a:pPr>
-            <a:r>
-              <a:rPr lang="ar-SA" b="1" dirty="0"/>
-              <a:t>الواجهة الخلفية (</a:t>
-            </a:r>
-            <a:r>
-              <a:rPr lang="en-US" b="1" dirty="0"/>
-              <a:t> :(Backend</a:t>
-            </a:r>
-            <a:r>
-              <a:rPr lang="ar-SA" dirty="0"/>
-              <a:t>لغة البرمجة </a:t>
-            </a:r>
-            <a:r>
-              <a:rPr lang="en-US" b="1" dirty="0"/>
-              <a:t>Python</a:t>
-            </a:r>
-            <a:r>
-              <a:rPr lang="en-US" dirty="0"/>
-              <a:t> </a:t>
-            </a:r>
-            <a:r>
-              <a:rPr lang="ar-SA" dirty="0"/>
-              <a:t> بالاعتماد على إطار العمل </a:t>
-            </a:r>
-            <a:r>
-              <a:rPr lang="en-US" dirty="0"/>
-              <a:t> (</a:t>
-            </a:r>
-            <a:r>
-              <a:rPr lang="en-US" b="1" dirty="0"/>
-              <a:t>Django)</a:t>
-            </a:r>
-            <a:r>
-              <a:rPr lang="ar-SA" dirty="0"/>
-              <a:t>لبناء بنية تحتية قوية، آمنة، وقابلة للتوسع.</a:t>
-            </a:r>
-          </a:p>
-          <a:p>
-            <a:pPr>
-              <a:lnSpc>
-                <a:spcPct val="150000"/>
-              </a:lnSpc>
-              <a:buFont typeface="Arial" panose="020B0604020202020204" pitchFamily="34" charset="0"/>
-              <a:buChar char="•"/>
-            </a:pPr>
-            <a:r>
-              <a:rPr lang="ar-SA" b="1" dirty="0"/>
-              <a:t>قواعد البيانات </a:t>
-            </a:r>
-            <a:r>
-              <a:rPr lang="en-US" b="1" dirty="0"/>
-              <a:t> :(Database)</a:t>
-            </a:r>
-            <a:r>
-              <a:rPr lang="ar-SA" dirty="0"/>
-              <a:t>قواعد بيانات علائقية</a:t>
-            </a:r>
-            <a:r>
-              <a:rPr lang="en-US" dirty="0"/>
-              <a:t> (</a:t>
-            </a:r>
-            <a:r>
-              <a:rPr lang="en-US" b="1" dirty="0"/>
-              <a:t>SQL) </a:t>
-            </a:r>
-            <a:r>
-              <a:rPr lang="ar-SA" dirty="0"/>
-              <a:t>لإدارة الملفات الشخصية، شروط الاستهداف، والردود بدقة وموثوقية).</a:t>
-            </a:r>
-          </a:p>
-          <a:p>
-            <a:pPr>
-              <a:lnSpc>
-                <a:spcPct val="150000"/>
-              </a:lnSpc>
-              <a:buFont typeface="Arial" panose="020B0604020202020204" pitchFamily="34" charset="0"/>
-              <a:buChar char="•"/>
-            </a:pPr>
-            <a:r>
-              <a:rPr lang="ar-SA" b="1" dirty="0"/>
-              <a:t>الواجهة الأمامية (</a:t>
-            </a:r>
-            <a:r>
-              <a:rPr lang="en-US" b="1" dirty="0"/>
-              <a:t>Frontend</a:t>
-            </a:r>
-            <a:r>
-              <a:rPr lang="ar-SA" b="1" dirty="0"/>
-              <a:t>): </a:t>
-            </a:r>
-            <a:r>
-              <a:rPr lang="ar-SA" dirty="0"/>
-              <a:t>تقنيات الويب القياسية </a:t>
-            </a:r>
-            <a:r>
-              <a:rPr lang="en-US" dirty="0"/>
-              <a:t> (HTML, CSS, JavaScript) </a:t>
-            </a:r>
-            <a:r>
-              <a:rPr lang="ar-SA" dirty="0"/>
-              <a:t>لتصميم واجهات مستخدم (</a:t>
-            </a:r>
-            <a:r>
-              <a:rPr lang="en-US" dirty="0"/>
-              <a:t>UI</a:t>
-            </a:r>
-            <a:r>
-              <a:rPr lang="ar-SA" dirty="0"/>
-              <a:t>) متجاوبة وسهلة الاستخدام.</a:t>
-            </a:r>
-          </a:p>
-          <a:p>
-            <a:pPr>
-              <a:lnSpc>
-                <a:spcPct val="150000"/>
-              </a:lnSpc>
-              <a:buFont typeface="Arial" panose="020B0604020202020204" pitchFamily="34" charset="0"/>
-              <a:buChar char="•"/>
-            </a:pPr>
-            <a:r>
-              <a:rPr lang="ar-SA" b="1" dirty="0"/>
-              <a:t>الذكاء الاصطناعي (</a:t>
-            </a:r>
-            <a:r>
-              <a:rPr lang="en-US" b="1" dirty="0"/>
-              <a:t> :(AI &amp; NLP</a:t>
-            </a:r>
-            <a:r>
-              <a:rPr lang="ar-SA" dirty="0"/>
-              <a:t>استغلال بيئة </a:t>
-            </a:r>
-            <a:r>
-              <a:rPr lang="en-US" dirty="0"/>
-              <a:t> Python </a:t>
-            </a:r>
-            <a:r>
-              <a:rPr lang="ar-SA" dirty="0"/>
-              <a:t>لدمج مكتبات ونماذج معالجة اللغات الطبيعية (لتحليل المشاعر واستخراج التوجهات).</a:t>
-            </a:r>
-          </a:p>
-        </p:txBody>
-      </p:sp>
-    </p:spTree>
-    <p:extLst>
-      <p:ext uri="{BB962C8B-B14F-4D97-AF65-F5344CB8AC3E}">
         <p14:creationId xmlns:p14="http://schemas.microsoft.com/office/powerpoint/2010/main" val="3741805348"/>
       </p:ext>
     </p:extLst>
@@ -5857,10 +6156,1418 @@
           <a:chExt cx="0" cy="0"/>
         </a:xfrm>
       </p:grpSpPr>
+      <p:pic>
+        <p:nvPicPr>
+          <p:cNvPr id="1026" name="Picture 2">
+            <a:extLst>
+              <a:ext uri="{FF2B5EF4-FFF2-40B4-BE49-F238E27FC236}">
+                <a16:creationId xmlns:a16="http://schemas.microsoft.com/office/drawing/2014/main" id="{6B91AAB6-8E48-1559-583A-D5828114BFCC}"/>
+              </a:ext>
+            </a:extLst>
+          </p:cNvPr>
+          <p:cNvPicPr>
+            <a:picLocks noChangeAspect="1" noChangeArrowheads="1"/>
+          </p:cNvPicPr>
+          <p:nvPr/>
+        </p:nvPicPr>
+        <p:blipFill>
+          <a:blip r:embed="rId2">
+            <a:extLst>
+              <a:ext uri="{28A0092B-C50C-407E-A947-70E740481C1C}">
+                <a14:useLocalDpi xmlns:a14="http://schemas.microsoft.com/office/drawing/2010/main" val="0"/>
+              </a:ext>
+            </a:extLst>
+          </a:blip>
+          <a:srcRect/>
+          <a:stretch>
+            <a:fillRect/>
+          </a:stretch>
+        </p:blipFill>
+        <p:spPr bwMode="auto">
+          <a:xfrm>
+            <a:off x="149290" y="112450"/>
+            <a:ext cx="11905861" cy="6605592"/>
+          </a:xfrm>
+          <a:prstGeom prst="rect">
+            <a:avLst/>
+          </a:prstGeom>
+          <a:ln w="88900" cap="sq" cmpd="thickThin">
+            <a:solidFill>
+              <a:srgbClr val="000000"/>
+            </a:solidFill>
+            <a:prstDash val="solid"/>
+            <a:miter lim="800000"/>
+          </a:ln>
+          <a:effectLst>
+            <a:innerShdw blurRad="76200">
+              <a:srgbClr val="000000"/>
+            </a:innerShdw>
+          </a:effectLst>
+          <a:extLst>
+            <a:ext uri="{909E8E84-426E-40DD-AFC4-6F175D3DCCD1}">
+              <a14:hiddenFill xmlns:a14="http://schemas.microsoft.com/office/drawing/2010/main">
+                <a:solidFill>
+                  <a:srgbClr val="FFFFFF"/>
+                </a:solidFill>
+              </a14:hiddenFill>
+            </a:ext>
+          </a:extLst>
+        </p:spPr>
+      </p:pic>
     </p:spTree>
     <p:extLst>
       <p:ext uri="{BB962C8B-B14F-4D97-AF65-F5344CB8AC3E}">
         <p14:creationId xmlns:p14="http://schemas.microsoft.com/office/powerpoint/2010/main" val="3130765992"/>
+      </p:ext>
+    </p:extLst>
+  </p:cSld>
+  <p:clrMapOvr>
+    <a:masterClrMapping/>
+  </p:clrMapOvr>
+</p:sld>
+</file>
+
+<file path=ppt/slides/slide7.xml><?xml version="1.0" encoding="utf-8"?>
+<p:sld xmlns:a="http://schemas.openxmlformats.org/drawingml/2006/main" xmlns:r="http://schemas.openxmlformats.org/officeDocument/2006/relationships" xmlns:p="http://schemas.openxmlformats.org/presentationml/2006/main">
+  <p:cSld>
+    <p:spTree>
+      <p:nvGrpSpPr>
+        <p:cNvPr id="1" name=""/>
+        <p:cNvGrpSpPr/>
+        <p:nvPr/>
+      </p:nvGrpSpPr>
+      <p:grpSpPr>
+        <a:xfrm>
+          <a:off x="0" y="0"/>
+          <a:ext cx="0" cy="0"/>
+          <a:chOff x="0" y="0"/>
+          <a:chExt cx="0" cy="0"/>
+        </a:xfrm>
+      </p:grpSpPr>
+      <p:sp>
+        <p:nvSpPr>
+          <p:cNvPr id="3" name="مربع نص 2">
+            <a:extLst>
+              <a:ext uri="{FF2B5EF4-FFF2-40B4-BE49-F238E27FC236}">
+                <a16:creationId xmlns:a16="http://schemas.microsoft.com/office/drawing/2014/main" id="{5FD39E78-D41F-8236-E1E0-A3D88CC477E0}"/>
+              </a:ext>
+            </a:extLst>
+          </p:cNvPr>
+          <p:cNvSpPr txBox="1"/>
+          <p:nvPr/>
+        </p:nvSpPr>
+        <p:spPr>
+          <a:xfrm>
+            <a:off x="502299" y="0"/>
+            <a:ext cx="11467321" cy="6282041"/>
+          </a:xfrm>
+          <a:prstGeom prst="rect">
+            <a:avLst/>
+          </a:prstGeom>
+          <a:noFill/>
+        </p:spPr>
+        <p:txBody>
+          <a:bodyPr wrap="square">
+            <a:spAutoFit/>
+          </a:bodyPr>
+          <a:lstStyle/>
+          <a:p>
+            <a:pPr>
+              <a:lnSpc>
+                <a:spcPct val="150000"/>
+              </a:lnSpc>
+            </a:pPr>
+            <a:r>
+              <a:rPr lang="ar-SA" sz="1500" b="1" dirty="0">
+                <a:solidFill>
+                  <a:schemeClr val="accent1"/>
+                </a:solidFill>
+              </a:rPr>
+              <a:t>المتطلبات الوظيفية</a:t>
+            </a:r>
+          </a:p>
+          <a:p>
+            <a:pPr>
+              <a:lnSpc>
+                <a:spcPct val="150000"/>
+              </a:lnSpc>
+            </a:pPr>
+            <a:r>
+              <a:rPr lang="ar-SA" sz="1500" b="1" dirty="0"/>
+              <a:t>1. وحدة إدارة الحسابات والمصادقة (</a:t>
+            </a:r>
+            <a:r>
+              <a:rPr lang="en-US" sz="1500" b="1" dirty="0"/>
+              <a:t>Authentication &amp; User Management)</a:t>
+            </a:r>
+            <a:endParaRPr lang="en-US" sz="1500" dirty="0"/>
+          </a:p>
+          <a:p>
+            <a:pPr>
+              <a:lnSpc>
+                <a:spcPct val="150000"/>
+              </a:lnSpc>
+              <a:buFont typeface="Arial" panose="020B0604020202020204" pitchFamily="34" charset="0"/>
+              <a:buChar char="•"/>
+            </a:pPr>
+            <a:r>
+              <a:rPr lang="ar-SA" sz="1500" dirty="0"/>
+              <a:t>يجب أن يتيح النظام إنشاء حسابات جديدة بتحديد نوع المستخدم (مقدم خدمة/باحث أو مُجيب).</a:t>
+            </a:r>
+          </a:p>
+          <a:p>
+            <a:pPr>
+              <a:lnSpc>
+                <a:spcPct val="150000"/>
+              </a:lnSpc>
+              <a:buFont typeface="Arial" panose="020B0604020202020204" pitchFamily="34" charset="0"/>
+              <a:buChar char="•"/>
+            </a:pPr>
+            <a:r>
+              <a:rPr lang="ar-SA" sz="1500" dirty="0"/>
+              <a:t>يجب أن يوفر النظام آلية لتسجيل الدخول الآمن واستعادة كلمة المرور.</a:t>
+            </a:r>
+          </a:p>
+          <a:p>
+            <a:pPr>
+              <a:lnSpc>
+                <a:spcPct val="150000"/>
+              </a:lnSpc>
+              <a:buFont typeface="Arial" panose="020B0604020202020204" pitchFamily="34" charset="0"/>
+              <a:buChar char="•"/>
+            </a:pPr>
+            <a:r>
+              <a:rPr lang="ar-SA" sz="1500" dirty="0"/>
+              <a:t>يجب أن يسمح النظام للمُجيبين بإدخال وتحديث بياناتهم الديموغرافية (العمر، الجنس، الموقع، الاهتمامات) في ملفاتهم الشخصية.</a:t>
+            </a:r>
+          </a:p>
+          <a:p>
+            <a:pPr>
+              <a:lnSpc>
+                <a:spcPct val="150000"/>
+              </a:lnSpc>
+            </a:pPr>
+            <a:r>
+              <a:rPr lang="ar-SA" sz="1500" b="1" dirty="0"/>
+              <a:t>2. وحدة إدارة الاستبيانات (</a:t>
+            </a:r>
+            <a:r>
+              <a:rPr lang="en-US" sz="1500" b="1" dirty="0"/>
+              <a:t> - Survey Management </a:t>
+            </a:r>
+            <a:r>
+              <a:rPr lang="ar-SA" sz="1500" b="1" dirty="0"/>
+              <a:t>لمقدم الخدمة)</a:t>
+            </a:r>
+            <a:endParaRPr lang="ar-SA" sz="1500" dirty="0"/>
+          </a:p>
+          <a:p>
+            <a:pPr>
+              <a:lnSpc>
+                <a:spcPct val="150000"/>
+              </a:lnSpc>
+              <a:buFont typeface="Arial" panose="020B0604020202020204" pitchFamily="34" charset="0"/>
+              <a:buChar char="•"/>
+            </a:pPr>
+            <a:r>
+              <a:rPr lang="ar-SA" sz="1500" dirty="0"/>
+              <a:t>يجب أن يمكن النظام مقدم الخدمة من إنشاء استبيان جديد وإضافة أسئلة متنوعة (نصية مفتوحة، خيارات متعددة).</a:t>
+            </a:r>
+          </a:p>
+          <a:p>
+            <a:pPr>
+              <a:lnSpc>
+                <a:spcPct val="150000"/>
+              </a:lnSpc>
+              <a:buFont typeface="Arial" panose="020B0604020202020204" pitchFamily="34" charset="0"/>
+              <a:buChar char="•"/>
+            </a:pPr>
+            <a:r>
+              <a:rPr lang="ar-SA" sz="1500" dirty="0"/>
+              <a:t>يجب أن يتيح النظام لمقدم الخدمة تحديد "شروط الاستهداف" (</a:t>
+            </a:r>
+            <a:r>
+              <a:rPr lang="en-US" sz="1500" dirty="0"/>
+              <a:t>Targeting Criteria) </a:t>
+            </a:r>
+            <a:r>
+              <a:rPr lang="ar-SA" sz="1500" dirty="0"/>
+              <a:t>لكل استبيان بناءً على البيانات الديموغرافية.</a:t>
+            </a:r>
+          </a:p>
+          <a:p>
+            <a:pPr>
+              <a:lnSpc>
+                <a:spcPct val="150000"/>
+              </a:lnSpc>
+            </a:pPr>
+            <a:r>
+              <a:rPr lang="ar-SA" sz="1500" b="1" dirty="0"/>
+              <a:t>3. وحدة محرك المطابقة (</a:t>
+            </a:r>
+            <a:r>
+              <a:rPr lang="en-US" sz="1500" b="1" dirty="0"/>
+              <a:t> - Targeting Engine </a:t>
+            </a:r>
+            <a:r>
+              <a:rPr lang="ar-SA" sz="1500" b="1" dirty="0"/>
+              <a:t>النظام الأساسي)</a:t>
+            </a:r>
+            <a:endParaRPr lang="ar-SA" sz="1500" dirty="0"/>
+          </a:p>
+          <a:p>
+            <a:pPr>
+              <a:lnSpc>
+                <a:spcPct val="150000"/>
+              </a:lnSpc>
+              <a:buFont typeface="Arial" panose="020B0604020202020204" pitchFamily="34" charset="0"/>
+              <a:buChar char="•"/>
+            </a:pPr>
+            <a:r>
+              <a:rPr lang="ar-SA" sz="1500" dirty="0"/>
+              <a:t>يجب أن يقوم النظام بمطابقة شروط الاستبيان مع قاعدة بيانات المُجيبين بشكل تلقائي.</a:t>
+            </a:r>
+          </a:p>
+          <a:p>
+            <a:pPr>
+              <a:lnSpc>
+                <a:spcPct val="150000"/>
+              </a:lnSpc>
+              <a:buFont typeface="Arial" panose="020B0604020202020204" pitchFamily="34" charset="0"/>
+              <a:buChar char="•"/>
+            </a:pPr>
+            <a:r>
+              <a:rPr lang="ar-SA" sz="1500" dirty="0"/>
+              <a:t>يجب أن يعرض النظام الاستبيانات المتاحة فقط للمُجيبين الذين تتطابق بياناتهم مع شروط الاستهداف.</a:t>
+            </a:r>
+          </a:p>
+          <a:p>
+            <a:pPr>
+              <a:lnSpc>
+                <a:spcPct val="150000"/>
+              </a:lnSpc>
+            </a:pPr>
+            <a:r>
+              <a:rPr lang="ar-SA" sz="1500" b="1" dirty="0"/>
+              <a:t>4. وحدة الإجابات والذكاء الاصطناعي (</a:t>
+            </a:r>
+            <a:r>
+              <a:rPr lang="en-US" sz="1500" b="1" dirty="0"/>
+              <a:t>Responses &amp; AI Integration</a:t>
+            </a:r>
+            <a:r>
+              <a:rPr lang="ar-SA" sz="1500" b="1" dirty="0"/>
+              <a:t>)</a:t>
+            </a:r>
+            <a:endParaRPr lang="en-US" sz="1500" dirty="0"/>
+          </a:p>
+          <a:p>
+            <a:pPr>
+              <a:lnSpc>
+                <a:spcPct val="150000"/>
+              </a:lnSpc>
+              <a:buFont typeface="Arial" panose="020B0604020202020204" pitchFamily="34" charset="0"/>
+              <a:buChar char="•"/>
+            </a:pPr>
+            <a:r>
+              <a:rPr lang="ar-SA" sz="1500" dirty="0"/>
+              <a:t>يجب أن يتيح النظام للمُجيبين إرسال إجاباتهم وحفظها في قاعدة البيانات.</a:t>
+            </a:r>
+          </a:p>
+          <a:p>
+            <a:pPr>
+              <a:lnSpc>
+                <a:spcPct val="150000"/>
+              </a:lnSpc>
+              <a:buFont typeface="Arial" panose="020B0604020202020204" pitchFamily="34" charset="0"/>
+              <a:buChar char="•"/>
+            </a:pPr>
+            <a:r>
+              <a:rPr lang="ar-SA" sz="1500" dirty="0"/>
+              <a:t>يجب أن يقوم النظام بتمرير الإجابات النصية المفتوحة إلى نموذج معالجة اللغات الطبيعية </a:t>
+            </a:r>
+            <a:r>
+              <a:rPr lang="en-US" sz="1500" dirty="0"/>
+              <a:t>.(NLP)</a:t>
+            </a:r>
+          </a:p>
+          <a:p>
+            <a:pPr>
+              <a:lnSpc>
+                <a:spcPct val="150000"/>
+              </a:lnSpc>
+              <a:buFont typeface="Arial" panose="020B0604020202020204" pitchFamily="34" charset="0"/>
+              <a:buChar char="•"/>
+            </a:pPr>
+            <a:r>
+              <a:rPr lang="ar-SA" sz="1500" dirty="0"/>
+              <a:t>يجب أن يصنف النظام الإجابات النصية تلقائياً إلى مشاعر (إيجابية، سلبية، محايدة).</a:t>
+            </a:r>
+          </a:p>
+          <a:p>
+            <a:pPr>
+              <a:lnSpc>
+                <a:spcPct val="150000"/>
+              </a:lnSpc>
+            </a:pPr>
+            <a:r>
+              <a:rPr lang="ar-SA" sz="1500" b="1" dirty="0"/>
+              <a:t>5. وحدة التقارير ولوحات التحكم (</a:t>
+            </a:r>
+            <a:r>
+              <a:rPr lang="en-US" sz="1500" b="1" dirty="0"/>
+              <a:t>(Dashboards &amp; Reporting</a:t>
+            </a:r>
+            <a:endParaRPr lang="en-US" sz="1500" dirty="0"/>
+          </a:p>
+          <a:p>
+            <a:pPr>
+              <a:lnSpc>
+                <a:spcPct val="150000"/>
+              </a:lnSpc>
+              <a:buFont typeface="Arial" panose="020B0604020202020204" pitchFamily="34" charset="0"/>
+              <a:buChar char="•"/>
+            </a:pPr>
+            <a:r>
+              <a:rPr lang="ar-SA" sz="1500" dirty="0"/>
+              <a:t>يجب أن يوفر النظام لوحة تحكم لمقدم الخدمة تعرض إحصائيات حية لعدد المجيبين.</a:t>
+            </a:r>
+          </a:p>
+          <a:p>
+            <a:pPr>
+              <a:lnSpc>
+                <a:spcPct val="150000"/>
+              </a:lnSpc>
+              <a:buFont typeface="Arial" panose="020B0604020202020204" pitchFamily="34" charset="0"/>
+              <a:buChar char="•"/>
+            </a:pPr>
+            <a:r>
+              <a:rPr lang="ar-SA" sz="1500" dirty="0"/>
+              <a:t>يجب أن يعرض النظام نتائج تحليل المشاعر (الذكاء الاصطناعي) على شكل رسوم بيانية تفاعلية.</a:t>
+            </a:r>
+          </a:p>
+        </p:txBody>
+      </p:sp>
+    </p:spTree>
+    <p:extLst>
+      <p:ext uri="{BB962C8B-B14F-4D97-AF65-F5344CB8AC3E}">
+        <p14:creationId xmlns:p14="http://schemas.microsoft.com/office/powerpoint/2010/main" val="2484457270"/>
+      </p:ext>
+    </p:extLst>
+  </p:cSld>
+  <p:clrMapOvr>
+    <a:masterClrMapping/>
+  </p:clrMapOvr>
+</p:sld>
+</file>
+
+<file path=ppt/slides/slide8.xml><?xml version="1.0" encoding="utf-8"?>
+<p:sld xmlns:a="http://schemas.openxmlformats.org/drawingml/2006/main" xmlns:r="http://schemas.openxmlformats.org/officeDocument/2006/relationships" xmlns:p="http://schemas.openxmlformats.org/presentationml/2006/main">
+  <p:cSld>
+    <p:spTree>
+      <p:nvGrpSpPr>
+        <p:cNvPr id="1" name=""/>
+        <p:cNvGrpSpPr/>
+        <p:nvPr/>
+      </p:nvGrpSpPr>
+      <p:grpSpPr>
+        <a:xfrm>
+          <a:off x="0" y="0"/>
+          <a:ext cx="0" cy="0"/>
+          <a:chOff x="0" y="0"/>
+          <a:chExt cx="0" cy="0"/>
+        </a:xfrm>
+      </p:grpSpPr>
+      <p:sp>
+        <p:nvSpPr>
+          <p:cNvPr id="4" name="مربع نص 3">
+            <a:extLst>
+              <a:ext uri="{FF2B5EF4-FFF2-40B4-BE49-F238E27FC236}">
+                <a16:creationId xmlns:a16="http://schemas.microsoft.com/office/drawing/2014/main" id="{94FE766C-8414-B6D3-12B6-103F4AC3BA32}"/>
+              </a:ext>
+            </a:extLst>
+          </p:cNvPr>
+          <p:cNvSpPr txBox="1"/>
+          <p:nvPr/>
+        </p:nvSpPr>
+        <p:spPr>
+          <a:xfrm>
+            <a:off x="342122" y="0"/>
+            <a:ext cx="11849878" cy="5909823"/>
+          </a:xfrm>
+          <a:prstGeom prst="rect">
+            <a:avLst/>
+          </a:prstGeom>
+          <a:noFill/>
+        </p:spPr>
+        <p:txBody>
+          <a:bodyPr wrap="square" rtlCol="1">
+            <a:spAutoFit/>
+          </a:bodyPr>
+          <a:lstStyle/>
+          <a:p>
+            <a:pPr>
+              <a:lnSpc>
+                <a:spcPct val="150000"/>
+              </a:lnSpc>
+            </a:pPr>
+            <a:r>
+              <a:rPr lang="ar-SA" sz="2000" b="1" dirty="0">
+                <a:solidFill>
+                  <a:schemeClr val="accent1"/>
+                </a:solidFill>
+              </a:rPr>
+              <a:t>المتطلبات غير وظيفية</a:t>
+            </a:r>
+          </a:p>
+          <a:p>
+            <a:pPr>
+              <a:lnSpc>
+                <a:spcPct val="150000"/>
+              </a:lnSpc>
+            </a:pPr>
+            <a:r>
+              <a:rPr lang="ar-SA" b="1" dirty="0"/>
+              <a:t>1.  الأداء والسرعة (</a:t>
+            </a:r>
+            <a:r>
+              <a:rPr lang="en-US" b="1" dirty="0"/>
+              <a:t>(Performance</a:t>
+            </a:r>
+            <a:endParaRPr lang="en-US" dirty="0"/>
+          </a:p>
+          <a:p>
+            <a:pPr>
+              <a:lnSpc>
+                <a:spcPct val="150000"/>
+              </a:lnSpc>
+              <a:buFont typeface="Arial" panose="020B0604020202020204" pitchFamily="34" charset="0"/>
+              <a:buChar char="•"/>
+            </a:pPr>
+            <a:r>
+              <a:rPr lang="ar-SA" sz="1600" dirty="0"/>
+              <a:t>يجب ألا يتجاوز زمن استجابة النظام لتمرير الإجابات لنموذج الذكاء الاصطناعي (</a:t>
+            </a:r>
+            <a:r>
+              <a:rPr lang="en-US" sz="1600" dirty="0"/>
+              <a:t> (NLP</a:t>
+            </a:r>
+            <a:r>
+              <a:rPr lang="ar-SA" sz="1600" dirty="0"/>
+              <a:t>وتحليلها 3 إلى 5 ثوانٍ.</a:t>
+            </a:r>
+          </a:p>
+          <a:p>
+            <a:pPr>
+              <a:lnSpc>
+                <a:spcPct val="150000"/>
+              </a:lnSpc>
+              <a:buFont typeface="Arial" panose="020B0604020202020204" pitchFamily="34" charset="0"/>
+              <a:buChar char="•"/>
+            </a:pPr>
+            <a:r>
+              <a:rPr lang="ar-SA" sz="1600" dirty="0"/>
+              <a:t>يجب تحميل صفحات الواجهة الأمامية بسرعة لضمان عدم ملل المستخدم أثناء الإجابة.</a:t>
+            </a:r>
+          </a:p>
+          <a:p>
+            <a:pPr>
+              <a:lnSpc>
+                <a:spcPct val="150000"/>
+              </a:lnSpc>
+            </a:pPr>
+            <a:r>
+              <a:rPr lang="ar-SA" b="1" dirty="0"/>
+              <a:t>2. الدقة (</a:t>
+            </a:r>
+            <a:r>
+              <a:rPr lang="en-US" b="1" dirty="0"/>
+              <a:t>Accuracy</a:t>
+            </a:r>
+            <a:r>
+              <a:rPr lang="ar-SA" b="1" dirty="0"/>
+              <a:t>)</a:t>
+            </a:r>
+            <a:endParaRPr lang="en-US" dirty="0"/>
+          </a:p>
+          <a:p>
+            <a:pPr>
+              <a:lnSpc>
+                <a:spcPct val="150000"/>
+              </a:lnSpc>
+              <a:buFont typeface="Arial" panose="020B0604020202020204" pitchFamily="34" charset="0"/>
+              <a:buChar char="•"/>
+            </a:pPr>
+            <a:r>
+              <a:rPr lang="ar-SA" sz="1600" dirty="0"/>
+              <a:t>يجب أن يحقق نموذج معالجة اللغات الطبيعية دقة تتراوح بين 75% إلى 80% في تصنيف المشاعر (إيجابي، سلبي، محايد) بشكل صحيح.</a:t>
+            </a:r>
+          </a:p>
+          <a:p>
+            <a:pPr>
+              <a:lnSpc>
+                <a:spcPct val="150000"/>
+              </a:lnSpc>
+            </a:pPr>
+            <a:r>
+              <a:rPr lang="ar-SA" b="1" dirty="0"/>
+              <a:t>3. الأمان والخصوصية </a:t>
+            </a:r>
+            <a:r>
+              <a:rPr lang="en-US" b="1" dirty="0"/>
+              <a:t>(Security &amp; Privacy)</a:t>
+            </a:r>
+            <a:endParaRPr lang="en-US" dirty="0"/>
+          </a:p>
+          <a:p>
+            <a:pPr>
+              <a:lnSpc>
+                <a:spcPct val="150000"/>
+              </a:lnSpc>
+              <a:buFont typeface="Arial" panose="020B0604020202020204" pitchFamily="34" charset="0"/>
+              <a:buChar char="•"/>
+            </a:pPr>
+            <a:r>
+              <a:rPr lang="ar-SA" sz="1600" dirty="0"/>
+              <a:t>يجب تشفير كلمات مرور المستخدمين في قاعدة البيانات ولا تُحفظ كنصوص مكشوفة (</a:t>
+            </a:r>
+            <a:r>
+              <a:rPr lang="en-US" sz="1600" dirty="0"/>
+              <a:t>(Hashing</a:t>
+            </a:r>
+          </a:p>
+          <a:p>
+            <a:pPr>
+              <a:lnSpc>
+                <a:spcPct val="150000"/>
+              </a:lnSpc>
+              <a:buFont typeface="Arial" panose="020B0604020202020204" pitchFamily="34" charset="0"/>
+              <a:buChar char="•"/>
+            </a:pPr>
+            <a:r>
+              <a:rPr lang="ar-SA" sz="1600" dirty="0"/>
+              <a:t>يجب حماية البيانات الديموغرافية للمجيبين ومنع الوصول غير المصرح به إليها، وحماية النظام من ثغرات الحقن (</a:t>
+            </a:r>
+            <a:r>
+              <a:rPr lang="en-US" sz="1600" dirty="0"/>
+              <a:t>(SQL Injection</a:t>
+            </a:r>
+          </a:p>
+          <a:p>
+            <a:pPr>
+              <a:lnSpc>
+                <a:spcPct val="150000"/>
+              </a:lnSpc>
+            </a:pPr>
+            <a:r>
+              <a:rPr lang="en-US" b="1" dirty="0"/>
+              <a:t> </a:t>
+            </a:r>
+            <a:r>
+              <a:rPr lang="ar-SA" b="1" dirty="0"/>
+              <a:t>4</a:t>
+            </a:r>
+            <a:r>
+              <a:rPr lang="en-US" b="1" dirty="0"/>
+              <a:t>.</a:t>
+            </a:r>
+            <a:r>
+              <a:rPr lang="ar-SA" b="1" dirty="0"/>
+              <a:t>  قابلية الاستخدام (</a:t>
+            </a:r>
+            <a:r>
+              <a:rPr lang="en-US" b="1" dirty="0"/>
+              <a:t>Usability</a:t>
+            </a:r>
+            <a:r>
+              <a:rPr lang="ar-SA" b="1" dirty="0"/>
+              <a:t>)</a:t>
+            </a:r>
+            <a:endParaRPr lang="en-US" dirty="0"/>
+          </a:p>
+          <a:p>
+            <a:pPr>
+              <a:lnSpc>
+                <a:spcPct val="150000"/>
+              </a:lnSpc>
+              <a:buFont typeface="Arial" panose="020B0604020202020204" pitchFamily="34" charset="0"/>
+              <a:buChar char="•"/>
+            </a:pPr>
+            <a:r>
+              <a:rPr lang="ar-SA" sz="1600" dirty="0"/>
+              <a:t>يجب أن تكون واجهات المنصة متجاوبة (</a:t>
+            </a:r>
+            <a:r>
+              <a:rPr lang="en-US" sz="1600" dirty="0"/>
+              <a:t>Responsive</a:t>
+            </a:r>
+            <a:r>
+              <a:rPr lang="ar-SA" sz="1600" dirty="0"/>
+              <a:t>) وتعمل بكفاءة على شاشات الحواسيب والهواتف المحمولة.</a:t>
+            </a:r>
+          </a:p>
+          <a:p>
+            <a:pPr>
+              <a:lnSpc>
+                <a:spcPct val="150000"/>
+              </a:lnSpc>
+              <a:buFont typeface="Arial" panose="020B0604020202020204" pitchFamily="34" charset="0"/>
+              <a:buChar char="•"/>
+            </a:pPr>
+            <a:r>
+              <a:rPr lang="ar-SA" sz="1600" dirty="0"/>
+              <a:t>يجب أن يكون مسار المستخدم بديهياً لتمكين الشركة أو الباحث من تصميم ونشر استبيان بخطوات واضحة وبسيطة.</a:t>
+            </a:r>
+          </a:p>
+          <a:p>
+            <a:pPr>
+              <a:lnSpc>
+                <a:spcPct val="150000"/>
+              </a:lnSpc>
+            </a:pPr>
+            <a:r>
+              <a:rPr lang="ar-SA" b="1" dirty="0"/>
+              <a:t>5. التوافرية وقابلية التوسع (</a:t>
+            </a:r>
+            <a:r>
+              <a:rPr lang="en-US" b="1" dirty="0"/>
+              <a:t>Availability &amp; Scalability</a:t>
+            </a:r>
+            <a:r>
+              <a:rPr lang="ar-SA" b="1" dirty="0"/>
+              <a:t>)</a:t>
+            </a:r>
+            <a:endParaRPr lang="en-US" b="1" dirty="0"/>
+          </a:p>
+          <a:p>
+            <a:pPr>
+              <a:lnSpc>
+                <a:spcPct val="150000"/>
+              </a:lnSpc>
+            </a:pPr>
+            <a:r>
+              <a:rPr lang="ar-SA" sz="1600" dirty="0"/>
+              <a:t>يجب أن يتحمل النظام دخول عدد محدد من المستخدمين (مثلاً 50 مستخدماً) في نفس الوقت للإجابة على استبيان واحد دون تعطل الخادم (وهو رقم واقعي لاختبار مشروع جامعي).</a:t>
+            </a:r>
+          </a:p>
+          <a:p>
+            <a:pPr>
+              <a:lnSpc>
+                <a:spcPct val="150000"/>
+              </a:lnSpc>
+            </a:pPr>
+            <a:endParaRPr lang="ar-SA" sz="1600" dirty="0"/>
+          </a:p>
+        </p:txBody>
+      </p:sp>
+    </p:spTree>
+    <p:extLst>
+      <p:ext uri="{BB962C8B-B14F-4D97-AF65-F5344CB8AC3E}">
+        <p14:creationId xmlns:p14="http://schemas.microsoft.com/office/powerpoint/2010/main" val="2662615565"/>
+      </p:ext>
+    </p:extLst>
+  </p:cSld>
+  <p:clrMapOvr>
+    <a:masterClrMapping/>
+  </p:clrMapOvr>
+</p:sld>
+</file>
+
+<file path=ppt/slides/slide9.xml><?xml version="1.0" encoding="utf-8"?>
+<p:sld xmlns:a="http://schemas.openxmlformats.org/drawingml/2006/main" xmlns:r="http://schemas.openxmlformats.org/officeDocument/2006/relationships" xmlns:p="http://schemas.openxmlformats.org/presentationml/2006/main">
+  <p:cSld>
+    <p:spTree>
+      <p:nvGrpSpPr>
+        <p:cNvPr id="1" name=""/>
+        <p:cNvGrpSpPr/>
+        <p:nvPr/>
+      </p:nvGrpSpPr>
+      <p:grpSpPr>
+        <a:xfrm>
+          <a:off x="0" y="0"/>
+          <a:ext cx="0" cy="0"/>
+          <a:chOff x="0" y="0"/>
+          <a:chExt cx="0" cy="0"/>
+        </a:xfrm>
+      </p:grpSpPr>
+      <p:sp>
+        <p:nvSpPr>
+          <p:cNvPr id="2" name="Rectangle 1">
+            <a:extLst>
+              <a:ext uri="{FF2B5EF4-FFF2-40B4-BE49-F238E27FC236}">
+                <a16:creationId xmlns:a16="http://schemas.microsoft.com/office/drawing/2014/main" id="{577396CD-93E4-6723-EC5E-95EAED088D56}"/>
+              </a:ext>
+            </a:extLst>
+          </p:cNvPr>
+          <p:cNvSpPr>
+            <a:spLocks noChangeArrowheads="1"/>
+          </p:cNvSpPr>
+          <p:nvPr/>
+        </p:nvSpPr>
+        <p:spPr bwMode="auto">
+          <a:xfrm>
+            <a:off x="2105220" y="761522"/>
+            <a:ext cx="9213973" cy="1287532"/>
+          </a:xfrm>
+          <a:prstGeom prst="rect">
+            <a:avLst/>
+          </a:prstGeom>
+          <a:noFill/>
+          <a:ln>
+            <a:noFill/>
+          </a:ln>
+          <a:effectLst/>
+          <a:extLst>
+            <a:ext uri="{909E8E84-426E-40DD-AFC4-6F175D3DCCD1}">
+              <a14:hiddenFill xmlns:a14="http://schemas.microsoft.com/office/drawing/2010/main">
+                <a:solidFill>
+                  <a:schemeClr val="accent1"/>
+                </a:solidFill>
+              </a14:hiddenFill>
+            </a:ext>
+            <a:ext uri="{91240B29-F687-4F45-9708-019B960494DF}">
+              <a14:hiddenLine xmlns:a14="http://schemas.microsoft.com/office/drawing/2010/main" w="9525">
+                <a:solidFill>
+                  <a:schemeClr val="tx1"/>
+                </a:solidFill>
+                <a:miter lim="800000"/>
+                <a:headEnd/>
+                <a:tailEnd/>
+              </a14:hiddenLine>
+            </a:ext>
+            <a:ext uri="{AF507438-7753-43E0-B8FC-AC1667EBCBE1}">
+              <a14:hiddenEffects xmlns:a14="http://schemas.microsoft.com/office/drawing/2010/main">
+                <a:effectLst>
+                  <a:outerShdw dist="35921" dir="2700000" algn="ctr" rotWithShape="0">
+                    <a:schemeClr val="bg2"/>
+                  </a:outerShdw>
+                </a:effectLst>
+              </a14:hiddenEffects>
+            </a:ext>
+          </a:extLst>
+        </p:spPr>
+        <p:txBody>
+          <a:bodyPr vert="horz" wrap="square" lIns="91440" tIns="45720" rIns="91440" bIns="45720" numCol="1" anchor="ctr" anchorCtr="0" compatLnSpc="1">
+            <a:prstTxWarp prst="textNoShape">
+              <a:avLst/>
+            </a:prstTxWarp>
+            <a:spAutoFit/>
+          </a:bodyPr>
+          <a:lstStyle/>
+          <a:p>
+            <a:pPr marL="0" marR="0" lvl="0" indent="0" defTabSz="914400" eaLnBrk="0" fontAlgn="base" latinLnBrk="0" hangingPunct="0">
+              <a:lnSpc>
+                <a:spcPct val="150000"/>
+              </a:lnSpc>
+              <a:spcBef>
+                <a:spcPct val="0"/>
+              </a:spcBef>
+              <a:spcAft>
+                <a:spcPct val="0"/>
+              </a:spcAft>
+              <a:buClrTx/>
+              <a:buSzTx/>
+              <a:buFontTx/>
+              <a:buChar char="•"/>
+              <a:tabLst/>
+            </a:pPr>
+            <a:r>
+              <a:rPr kumimoji="0" lang="ar-SA" altLang="ar-SA" b="1" i="0" u="none" strike="noStrike" cap="none" normalizeH="0" baseline="0" dirty="0">
+                <a:ln>
+                  <a:noFill/>
+                </a:ln>
+                <a:solidFill>
+                  <a:schemeClr val="tx1"/>
+                </a:solidFill>
+                <a:effectLst/>
+                <a:latin typeface="Arial" panose="020B0604020202020204" pitchFamily="34" charset="0"/>
+                <a:cs typeface="Arial" panose="020B0604020202020204" pitchFamily="34" charset="0"/>
+              </a:rPr>
+              <a:t> مقدم الخدمة / الباحث (Survey Creator):</a:t>
+            </a:r>
+            <a:r>
+              <a:rPr lang="ar-SA" altLang="ar-SA" dirty="0">
+                <a:latin typeface="Arial" panose="020B0604020202020204" pitchFamily="34" charset="0"/>
+              </a:rPr>
+              <a:t> </a:t>
+            </a:r>
+            <a:r>
+              <a:rPr kumimoji="0" lang="ar-SA" altLang="ar-SA" sz="1600" b="0" i="0" u="none" strike="noStrike" cap="none" normalizeH="0" baseline="0" dirty="0">
+                <a:ln>
+                  <a:noFill/>
+                </a:ln>
+                <a:solidFill>
+                  <a:schemeClr val="tx1"/>
+                </a:solidFill>
+                <a:effectLst/>
+                <a:latin typeface="Arial" panose="020B0604020202020204" pitchFamily="34" charset="0"/>
+                <a:cs typeface="Arial" panose="020B0604020202020204" pitchFamily="34" charset="0"/>
+              </a:rPr>
+              <a:t>الجهة المستفيدة من المنصة لجمع البيانات.</a:t>
+            </a:r>
+            <a:endParaRPr kumimoji="0" lang="ar-SA" altLang="ar-SA" sz="1600" b="0" i="0" u="none" strike="noStrike" cap="none" normalizeH="0" baseline="0" dirty="0">
+              <a:ln>
+                <a:noFill/>
+              </a:ln>
+              <a:solidFill>
+                <a:schemeClr val="tx1"/>
+              </a:solidFill>
+              <a:effectLst/>
+              <a:latin typeface="Arial" panose="020B0604020202020204" pitchFamily="34" charset="0"/>
+            </a:endParaRPr>
+          </a:p>
+          <a:p>
+            <a:pPr marL="0" marR="0" lvl="0" indent="0" defTabSz="914400" eaLnBrk="0" fontAlgn="base" latinLnBrk="0" hangingPunct="0">
+              <a:lnSpc>
+                <a:spcPct val="150000"/>
+              </a:lnSpc>
+              <a:spcBef>
+                <a:spcPct val="0"/>
+              </a:spcBef>
+              <a:spcAft>
+                <a:spcPct val="0"/>
+              </a:spcAft>
+              <a:buClrTx/>
+              <a:buSzTx/>
+              <a:buFontTx/>
+              <a:buChar char="•"/>
+              <a:tabLst/>
+            </a:pPr>
+            <a:r>
+              <a:rPr kumimoji="0" lang="ar-SA" altLang="ar-SA" b="1" i="0" u="none" strike="noStrike" cap="none" normalizeH="0" baseline="0" dirty="0">
+                <a:ln>
+                  <a:noFill/>
+                </a:ln>
+                <a:solidFill>
+                  <a:schemeClr val="tx1"/>
+                </a:solidFill>
+                <a:effectLst/>
+                <a:latin typeface="Arial" panose="020B0604020202020204" pitchFamily="34" charset="0"/>
+                <a:cs typeface="Arial" panose="020B0604020202020204" pitchFamily="34" charset="0"/>
+              </a:rPr>
+              <a:t> المستخدم المُجيب (Respondent): </a:t>
+            </a:r>
+            <a:r>
+              <a:rPr kumimoji="0" lang="ar-SA" altLang="ar-SA" sz="1600" b="0" i="0" u="none" strike="noStrike" cap="none" normalizeH="0" baseline="0" dirty="0">
+                <a:ln>
+                  <a:noFill/>
+                </a:ln>
+                <a:solidFill>
+                  <a:schemeClr val="tx1"/>
+                </a:solidFill>
+                <a:effectLst/>
+                <a:latin typeface="Arial" panose="020B0604020202020204" pitchFamily="34" charset="0"/>
+                <a:cs typeface="Arial" panose="020B0604020202020204" pitchFamily="34" charset="0"/>
+              </a:rPr>
+              <a:t>الفرد المستهدف للإجابة على الاستبيانات.</a:t>
+            </a:r>
+            <a:endParaRPr kumimoji="0" lang="ar-SA" altLang="ar-SA" sz="1600" b="0" i="0" u="none" strike="noStrike" cap="none" normalizeH="0" baseline="0" dirty="0">
+              <a:ln>
+                <a:noFill/>
+              </a:ln>
+              <a:solidFill>
+                <a:schemeClr val="tx1"/>
+              </a:solidFill>
+              <a:effectLst/>
+              <a:latin typeface="Arial" panose="020B0604020202020204" pitchFamily="34" charset="0"/>
+            </a:endParaRPr>
+          </a:p>
+          <a:p>
+            <a:pPr marL="0" marR="0" lvl="0" indent="0" defTabSz="914400" eaLnBrk="0" fontAlgn="base" latinLnBrk="0" hangingPunct="0">
+              <a:lnSpc>
+                <a:spcPct val="150000"/>
+              </a:lnSpc>
+              <a:spcBef>
+                <a:spcPct val="0"/>
+              </a:spcBef>
+              <a:spcAft>
+                <a:spcPct val="0"/>
+              </a:spcAft>
+              <a:buClrTx/>
+              <a:buSzTx/>
+              <a:buFontTx/>
+              <a:buChar char="•"/>
+              <a:tabLst/>
+            </a:pPr>
+            <a:r>
+              <a:rPr kumimoji="0" lang="ar-SA" altLang="ar-SA" b="1" i="0" u="none" strike="noStrike" cap="none" normalizeH="0" baseline="0" dirty="0">
+                <a:ln>
+                  <a:noFill/>
+                </a:ln>
+                <a:solidFill>
+                  <a:schemeClr val="tx1"/>
+                </a:solidFill>
+                <a:effectLst/>
+                <a:latin typeface="Arial" panose="020B0604020202020204" pitchFamily="34" charset="0"/>
+                <a:cs typeface="Arial" panose="020B0604020202020204" pitchFamily="34" charset="0"/>
+              </a:rPr>
+              <a:t> مدير النظام (System Administrator):</a:t>
+            </a:r>
+            <a:r>
+              <a:rPr lang="ar-SA" altLang="ar-SA" sz="1600" dirty="0">
+                <a:latin typeface="Arial" panose="020B0604020202020204" pitchFamily="34" charset="0"/>
+                <a:cs typeface="Arial" panose="020B0604020202020204" pitchFamily="34" charset="0"/>
+              </a:rPr>
+              <a:t> </a:t>
+            </a:r>
+            <a:r>
+              <a:rPr kumimoji="0" lang="ar-SA" altLang="ar-SA" sz="1600" b="0" i="0" u="none" strike="noStrike" cap="none" normalizeH="0" baseline="0" dirty="0">
+                <a:ln>
+                  <a:noFill/>
+                </a:ln>
+                <a:solidFill>
+                  <a:schemeClr val="tx1"/>
+                </a:solidFill>
+                <a:effectLst/>
+                <a:latin typeface="Arial" panose="020B0604020202020204" pitchFamily="34" charset="0"/>
+                <a:cs typeface="Arial" panose="020B0604020202020204" pitchFamily="34" charset="0"/>
+              </a:rPr>
+              <a:t>المشرف التقني على المنصة.</a:t>
+            </a:r>
+            <a:endParaRPr kumimoji="0" lang="ar-SA" altLang="ar-SA" sz="1600" b="0" i="0" u="none" strike="noStrike" cap="none" normalizeH="0" baseline="0" dirty="0">
+              <a:ln>
+                <a:noFill/>
+              </a:ln>
+              <a:solidFill>
+                <a:schemeClr val="tx1"/>
+              </a:solidFill>
+              <a:effectLst/>
+              <a:latin typeface="Arial" panose="020B0604020202020204" pitchFamily="34" charset="0"/>
+            </a:endParaRPr>
+          </a:p>
+        </p:txBody>
+      </p:sp>
+      <p:sp>
+        <p:nvSpPr>
+          <p:cNvPr id="3" name="مربع نص 2">
+            <a:extLst>
+              <a:ext uri="{FF2B5EF4-FFF2-40B4-BE49-F238E27FC236}">
+                <a16:creationId xmlns:a16="http://schemas.microsoft.com/office/drawing/2014/main" id="{2015423A-1BA5-AA35-708F-4B3914C45213}"/>
+              </a:ext>
+            </a:extLst>
+          </p:cNvPr>
+          <p:cNvSpPr txBox="1"/>
+          <p:nvPr/>
+        </p:nvSpPr>
+        <p:spPr>
+          <a:xfrm>
+            <a:off x="9038252" y="156517"/>
+            <a:ext cx="3013788" cy="584775"/>
+          </a:xfrm>
+          <a:prstGeom prst="rect">
+            <a:avLst/>
+          </a:prstGeom>
+          <a:noFill/>
+        </p:spPr>
+        <p:txBody>
+          <a:bodyPr wrap="square" rtlCol="1">
+            <a:spAutoFit/>
+          </a:bodyPr>
+          <a:lstStyle/>
+          <a:p>
+            <a:pPr algn="ctr"/>
+            <a:r>
+              <a:rPr lang="en-US" sz="3200" b="1" dirty="0">
+                <a:solidFill>
+                  <a:schemeClr val="accent1"/>
+                </a:solidFill>
+              </a:rPr>
+              <a:t>Actors</a:t>
+            </a:r>
+            <a:endParaRPr lang="ar-SA" b="1" dirty="0">
+              <a:solidFill>
+                <a:schemeClr val="accent1"/>
+              </a:solidFill>
+            </a:endParaRPr>
+          </a:p>
+        </p:txBody>
+      </p:sp>
+      <p:sp>
+        <p:nvSpPr>
+          <p:cNvPr id="7" name="مربع نص 6">
+            <a:extLst>
+              <a:ext uri="{FF2B5EF4-FFF2-40B4-BE49-F238E27FC236}">
+                <a16:creationId xmlns:a16="http://schemas.microsoft.com/office/drawing/2014/main" id="{73906974-904E-BDCD-A93D-E3B9C0E1FF56}"/>
+              </a:ext>
+            </a:extLst>
+          </p:cNvPr>
+          <p:cNvSpPr txBox="1"/>
+          <p:nvPr/>
+        </p:nvSpPr>
+        <p:spPr>
+          <a:xfrm>
+            <a:off x="7785619" y="3255526"/>
+            <a:ext cx="3533574" cy="3365024"/>
+          </a:xfrm>
+          <a:prstGeom prst="rect">
+            <a:avLst/>
+          </a:prstGeom>
+          <a:noFill/>
+        </p:spPr>
+        <p:txBody>
+          <a:bodyPr wrap="square">
+            <a:spAutoFit/>
+          </a:bodyPr>
+          <a:lstStyle/>
+          <a:p>
+            <a:pPr>
+              <a:lnSpc>
+                <a:spcPct val="150000"/>
+              </a:lnSpc>
+            </a:pPr>
+            <a:r>
+              <a:rPr lang="ar-SA" b="1" dirty="0"/>
+              <a:t>مقدم الخدمة (الشركة / الباحث):</a:t>
+            </a:r>
+            <a:endParaRPr lang="ar-SA" dirty="0"/>
+          </a:p>
+          <a:p>
+            <a:pPr>
+              <a:lnSpc>
+                <a:spcPct val="150000"/>
+              </a:lnSpc>
+              <a:buFont typeface="Arial" panose="020B0604020202020204" pitchFamily="34" charset="0"/>
+              <a:buChar char="•"/>
+            </a:pPr>
+            <a:r>
+              <a:rPr lang="ar-SA" dirty="0"/>
+              <a:t>إنشاء حساب</a:t>
+            </a:r>
+          </a:p>
+          <a:p>
+            <a:pPr>
+              <a:lnSpc>
+                <a:spcPct val="150000"/>
+              </a:lnSpc>
+              <a:buFont typeface="Arial" panose="020B0604020202020204" pitchFamily="34" charset="0"/>
+              <a:buChar char="•"/>
+            </a:pPr>
+            <a:r>
+              <a:rPr lang="ar-SA" dirty="0"/>
+              <a:t>إدارة الاستبيانات (تشمل الإنشاء والتعديل)</a:t>
+            </a:r>
+          </a:p>
+          <a:p>
+            <a:pPr>
+              <a:lnSpc>
+                <a:spcPct val="150000"/>
+              </a:lnSpc>
+              <a:buFont typeface="Arial" panose="020B0604020202020204" pitchFamily="34" charset="0"/>
+              <a:buChar char="•"/>
+            </a:pPr>
+            <a:r>
+              <a:rPr lang="ar-SA" dirty="0"/>
+              <a:t>تحديد شروط الاستهداف</a:t>
+            </a:r>
+          </a:p>
+          <a:p>
+            <a:pPr>
+              <a:lnSpc>
+                <a:spcPct val="150000"/>
+              </a:lnSpc>
+              <a:buFont typeface="Arial" panose="020B0604020202020204" pitchFamily="34" charset="0"/>
+              <a:buChar char="•"/>
+            </a:pPr>
+            <a:r>
+              <a:rPr lang="ar-SA" dirty="0"/>
+              <a:t>استعراض نتائج تحليل المشاعر</a:t>
+            </a:r>
+          </a:p>
+          <a:p>
+            <a:pPr>
+              <a:lnSpc>
+                <a:spcPct val="150000"/>
+              </a:lnSpc>
+              <a:buFont typeface="Arial" panose="020B0604020202020204" pitchFamily="34" charset="0"/>
+              <a:buChar char="•"/>
+            </a:pPr>
+            <a:r>
+              <a:rPr lang="ar-SA" dirty="0"/>
+              <a:t>تسجيل الدخول</a:t>
+            </a:r>
+          </a:p>
+          <a:p>
+            <a:pPr>
+              <a:lnSpc>
+                <a:spcPct val="150000"/>
+              </a:lnSpc>
+              <a:buFont typeface="Arial" panose="020B0604020202020204" pitchFamily="34" charset="0"/>
+              <a:buChar char="•"/>
+            </a:pPr>
+            <a:r>
+              <a:rPr lang="ar-SA" dirty="0"/>
+              <a:t> تسجيل الخروج</a:t>
+            </a:r>
+          </a:p>
+          <a:p>
+            <a:pPr>
+              <a:lnSpc>
+                <a:spcPct val="150000"/>
+              </a:lnSpc>
+            </a:pPr>
+            <a:endParaRPr lang="ar-SA" dirty="0"/>
+          </a:p>
+        </p:txBody>
+      </p:sp>
+      <p:sp>
+        <p:nvSpPr>
+          <p:cNvPr id="9" name="مربع نص 8">
+            <a:extLst>
+              <a:ext uri="{FF2B5EF4-FFF2-40B4-BE49-F238E27FC236}">
+                <a16:creationId xmlns:a16="http://schemas.microsoft.com/office/drawing/2014/main" id="{EFCD7154-06EF-7EF3-D731-6FB4A357D155}"/>
+              </a:ext>
+            </a:extLst>
+          </p:cNvPr>
+          <p:cNvSpPr txBox="1"/>
+          <p:nvPr/>
+        </p:nvSpPr>
+        <p:spPr>
+          <a:xfrm>
+            <a:off x="3890865" y="2606335"/>
+            <a:ext cx="7428328" cy="461665"/>
+          </a:xfrm>
+          <a:prstGeom prst="rect">
+            <a:avLst/>
+          </a:prstGeom>
+          <a:noFill/>
+        </p:spPr>
+        <p:txBody>
+          <a:bodyPr wrap="square">
+            <a:spAutoFit/>
+          </a:bodyPr>
+          <a:lstStyle/>
+          <a:p>
+            <a:r>
+              <a:rPr lang="ar-SA" sz="2400" b="1" dirty="0">
+                <a:solidFill>
+                  <a:schemeClr val="accent1"/>
+                </a:solidFill>
+              </a:rPr>
+              <a:t>حالات الاستخدام حسب الفاعلين (</a:t>
+            </a:r>
+            <a:r>
+              <a:rPr lang="en-US" sz="2400" b="1" dirty="0">
+                <a:solidFill>
+                  <a:schemeClr val="accent1"/>
+                </a:solidFill>
+              </a:rPr>
+              <a:t>(Use Cases by Actors</a:t>
+            </a:r>
+            <a:endParaRPr lang="ar-SA" sz="2400" b="1" dirty="0">
+              <a:solidFill>
+                <a:schemeClr val="accent1"/>
+              </a:solidFill>
+            </a:endParaRPr>
+          </a:p>
+        </p:txBody>
+      </p:sp>
+      <p:sp>
+        <p:nvSpPr>
+          <p:cNvPr id="11" name="مربع نص 10">
+            <a:extLst>
+              <a:ext uri="{FF2B5EF4-FFF2-40B4-BE49-F238E27FC236}">
+                <a16:creationId xmlns:a16="http://schemas.microsoft.com/office/drawing/2014/main" id="{CE8152E0-698A-86B7-7B47-C9999DE2B867}"/>
+              </a:ext>
+            </a:extLst>
+          </p:cNvPr>
+          <p:cNvSpPr txBox="1"/>
+          <p:nvPr/>
+        </p:nvSpPr>
+        <p:spPr>
+          <a:xfrm>
+            <a:off x="831009" y="3260620"/>
+            <a:ext cx="3725246" cy="2805320"/>
+          </a:xfrm>
+          <a:prstGeom prst="rect">
+            <a:avLst/>
+          </a:prstGeom>
+          <a:noFill/>
+        </p:spPr>
+        <p:txBody>
+          <a:bodyPr wrap="square">
+            <a:spAutoFit/>
+          </a:bodyPr>
+          <a:lstStyle/>
+          <a:p>
+            <a:pPr>
+              <a:lnSpc>
+                <a:spcPct val="150000"/>
+              </a:lnSpc>
+            </a:pPr>
+            <a:r>
+              <a:rPr lang="ar-SA" sz="2000" b="1" dirty="0"/>
+              <a:t>المُجيب (المستخدم):</a:t>
+            </a:r>
+            <a:endParaRPr lang="ar-SA" sz="2000" dirty="0"/>
+          </a:p>
+          <a:p>
+            <a:pPr>
+              <a:lnSpc>
+                <a:spcPct val="150000"/>
+              </a:lnSpc>
+              <a:buFont typeface="Arial" panose="020B0604020202020204" pitchFamily="34" charset="0"/>
+              <a:buChar char="•"/>
+            </a:pPr>
+            <a:r>
+              <a:rPr lang="ar-SA" sz="2000" dirty="0"/>
+              <a:t>إنشاء حساب</a:t>
+            </a:r>
+          </a:p>
+          <a:p>
+            <a:pPr>
+              <a:lnSpc>
+                <a:spcPct val="150000"/>
+              </a:lnSpc>
+              <a:buFont typeface="Arial" panose="020B0604020202020204" pitchFamily="34" charset="0"/>
+              <a:buChar char="•"/>
+            </a:pPr>
+            <a:r>
+              <a:rPr lang="ar-SA" sz="2000" dirty="0"/>
+              <a:t>إدارة الملف الديموغرافي</a:t>
+            </a:r>
+          </a:p>
+          <a:p>
+            <a:pPr>
+              <a:lnSpc>
+                <a:spcPct val="150000"/>
+              </a:lnSpc>
+              <a:buFont typeface="Arial" panose="020B0604020202020204" pitchFamily="34" charset="0"/>
+              <a:buChar char="•"/>
+            </a:pPr>
+            <a:r>
+              <a:rPr lang="ar-SA" sz="2000" dirty="0"/>
+              <a:t>الإجابة على الاستبيانات المطابقة</a:t>
+            </a:r>
+          </a:p>
+          <a:p>
+            <a:pPr>
+              <a:lnSpc>
+                <a:spcPct val="150000"/>
+              </a:lnSpc>
+              <a:buFont typeface="Arial" panose="020B0604020202020204" pitchFamily="34" charset="0"/>
+              <a:buChar char="•"/>
+            </a:pPr>
+            <a:r>
+              <a:rPr lang="ar-SA" sz="2000" dirty="0"/>
+              <a:t>تسجيل الدخول</a:t>
+            </a:r>
+          </a:p>
+          <a:p>
+            <a:pPr>
+              <a:lnSpc>
+                <a:spcPct val="150000"/>
+              </a:lnSpc>
+              <a:buFont typeface="Arial" panose="020B0604020202020204" pitchFamily="34" charset="0"/>
+              <a:buChar char="•"/>
+            </a:pPr>
+            <a:r>
+              <a:rPr lang="ar-SA" sz="2000" dirty="0"/>
+              <a:t> تسجيل الخروج</a:t>
+            </a:r>
+          </a:p>
+        </p:txBody>
+      </p:sp>
+      <p:sp>
+        <p:nvSpPr>
+          <p:cNvPr id="14" name="مربع نص 13">
+            <a:extLst>
+              <a:ext uri="{FF2B5EF4-FFF2-40B4-BE49-F238E27FC236}">
+                <a16:creationId xmlns:a16="http://schemas.microsoft.com/office/drawing/2014/main" id="{0DB0DE35-0EE9-AC75-31FC-364187A3F4C7}"/>
+              </a:ext>
+            </a:extLst>
+          </p:cNvPr>
+          <p:cNvSpPr txBox="1"/>
+          <p:nvPr/>
+        </p:nvSpPr>
+        <p:spPr>
+          <a:xfrm>
+            <a:off x="5221639" y="3260620"/>
+            <a:ext cx="2514215" cy="2343655"/>
+          </a:xfrm>
+          <a:prstGeom prst="rect">
+            <a:avLst/>
+          </a:prstGeom>
+          <a:noFill/>
+        </p:spPr>
+        <p:txBody>
+          <a:bodyPr wrap="square">
+            <a:spAutoFit/>
+          </a:bodyPr>
+          <a:lstStyle/>
+          <a:p>
+            <a:pPr>
+              <a:lnSpc>
+                <a:spcPct val="150000"/>
+              </a:lnSpc>
+            </a:pPr>
+            <a:r>
+              <a:rPr lang="ar-SA" sz="2000" b="1" dirty="0"/>
+              <a:t>مدير النظام (</a:t>
+            </a:r>
+            <a:r>
+              <a:rPr lang="en-US" sz="2000" b="1" dirty="0"/>
+              <a:t>(Admin</a:t>
+            </a:r>
+            <a:endParaRPr lang="en-US" sz="2000" dirty="0"/>
+          </a:p>
+          <a:p>
+            <a:pPr>
+              <a:lnSpc>
+                <a:spcPct val="150000"/>
+              </a:lnSpc>
+              <a:buFont typeface="Arial" panose="020B0604020202020204" pitchFamily="34" charset="0"/>
+              <a:buChar char="•"/>
+            </a:pPr>
+            <a:r>
+              <a:rPr lang="ar-SA" sz="2000" dirty="0"/>
+              <a:t>إدارة الحسابات </a:t>
+            </a:r>
+          </a:p>
+          <a:p>
+            <a:pPr>
+              <a:lnSpc>
+                <a:spcPct val="150000"/>
+              </a:lnSpc>
+              <a:buFont typeface="Arial" panose="020B0604020202020204" pitchFamily="34" charset="0"/>
+              <a:buChar char="•"/>
+            </a:pPr>
+            <a:r>
+              <a:rPr lang="ar-SA" sz="2000" dirty="0"/>
+              <a:t>استخراج تقارير الأداء العام</a:t>
+            </a:r>
+          </a:p>
+          <a:p>
+            <a:pPr>
+              <a:lnSpc>
+                <a:spcPct val="150000"/>
+              </a:lnSpc>
+              <a:buFont typeface="Arial" panose="020B0604020202020204" pitchFamily="34" charset="0"/>
+              <a:buChar char="•"/>
+            </a:pPr>
+            <a:r>
+              <a:rPr lang="ar-SA" sz="2000" dirty="0"/>
+              <a:t>تسجيل الدخول</a:t>
+            </a:r>
+          </a:p>
+          <a:p>
+            <a:pPr>
+              <a:lnSpc>
+                <a:spcPct val="150000"/>
+              </a:lnSpc>
+              <a:buFont typeface="Arial" panose="020B0604020202020204" pitchFamily="34" charset="0"/>
+              <a:buChar char="•"/>
+            </a:pPr>
+            <a:r>
+              <a:rPr lang="ar-SA" sz="2000" dirty="0"/>
+              <a:t> تسجيل الخروج</a:t>
+            </a:r>
+          </a:p>
+        </p:txBody>
+      </p:sp>
+    </p:spTree>
+    <p:extLst>
+      <p:ext uri="{BB962C8B-B14F-4D97-AF65-F5344CB8AC3E}">
+        <p14:creationId xmlns:p14="http://schemas.microsoft.com/office/powerpoint/2010/main" val="244173729"/>
       </p:ext>
     </p:extLst>
   </p:cSld>

</xml_diff>